<commit_message>
Assemble editable 16:9 AI chain PPT from discrete assets
Generate separate hero images, column icons, and metric icons,
then compose them as native PowerPoint shapes, text boxes, and
pictures so every element is individually editable/replaceable.

Co-authored-by: Junwei Wang <junweiwangwjw@icloud.com>
</commit_message>
<xml_diff>
--- a/AI-industry-chain-editable-16x9.pptx
+++ b/AI-industry-chain-editable-16x9.pptx
@@ -6,7 +6,6 @@
   </p:sldMasterIdLst>
   <p:sldIdLst>
     <p:sldId id="256" r:id="rId7"/>
-    <p:sldId id="257" r:id="rId8"/>
   </p:sldIdLst>
   <p:sldSz cx="12191695" cy="6858000" type="screen4x3"/>
   <p:notesSz cx="6858000" cy="9144000"/>
@@ -3141,7 +3140,7 @@
         <p:spPr>
           <a:xfrm>
             <a:off x="0" y="0"/>
-            <a:ext cx="12191695" cy="1417320"/>
+            <a:ext cx="12191695" cy="1325880"/>
           </a:xfrm>
           <a:prstGeom prst="rect">
             <a:avLst/>
@@ -3183,8 +3182,8 @@
         </p:nvSpPr>
         <p:spPr>
           <a:xfrm>
-            <a:off x="411480" y="256032"/>
-            <a:ext cx="11155680" cy="594360"/>
+            <a:off x="365760" y="228600"/>
+            <a:ext cx="11338560" cy="548640"/>
           </a:xfrm>
           <a:prstGeom prst="rect">
             <a:avLst/>
@@ -3198,6 +3197,9 @@
           <a:lstStyle/>
           <a:p>
             <a:pPr algn="l">
+              <a:spcAft>
+                <a:spcPts val="200"/>
+              </a:spcAft>
               <a:defRPr sz="2800" b="1">
                 <a:solidFill>
                   <a:srgbClr val="FFFFFF"/>
@@ -3219,8 +3221,8 @@
         </p:nvSpPr>
         <p:spPr>
           <a:xfrm>
-            <a:off x="411480" y="868680"/>
-            <a:ext cx="11155680" cy="365760"/>
+            <a:off x="365760" y="822960"/>
+            <a:ext cx="11338560" cy="365760"/>
           </a:xfrm>
           <a:prstGeom prst="rect">
             <a:avLst/>
@@ -3234,7 +3236,10 @@
           <a:lstStyle/>
           <a:p>
             <a:pPr algn="l">
-              <a:defRPr sz="1600" b="0">
+              <a:spcAft>
+                <a:spcPts val="200"/>
+              </a:spcAft>
+              <a:defRPr sz="1500" b="0">
                 <a:solidFill>
                   <a:srgbClr val="B4BED2"/>
                 </a:solidFill>
@@ -3255,16 +3260,18 @@
         </p:nvSpPr>
         <p:spPr>
           <a:xfrm>
-            <a:off x="320040" y="1600200"/>
-            <a:ext cx="2178649" cy="3977639"/>
+            <a:off x="274320" y="1508760"/>
+            <a:ext cx="2211567" cy="4114800"/>
           </a:xfrm>
           <a:prstGeom prst="roundRect">
-            <a:avLst/>
+            <a:avLst>
+              <a:gd name="adj" fmla="val 8000"/>
+            </a:avLst>
           </a:prstGeom>
           <a:solidFill>
             <a:srgbClr val="0E1C32"/>
           </a:solidFill>
-          <a:ln>
+          <a:ln w="12700">
             <a:solidFill>
               <a:srgbClr val="1E375A"/>
             </a:solidFill>
@@ -3300,8 +3307,8 @@
         </p:nvSpPr>
         <p:spPr>
           <a:xfrm>
-            <a:off x="411480" y="1709928"/>
-            <a:ext cx="1995769" cy="384048"/>
+            <a:off x="347472" y="1618488"/>
+            <a:ext cx="2065263" cy="365760"/>
           </a:xfrm>
           <a:prstGeom prst="rect">
             <a:avLst/>
@@ -3315,7 +3322,10 @@
           <a:lstStyle/>
           <a:p>
             <a:pPr algn="ctr">
-              <a:defRPr sz="2000" b="1">
+              <a:spcAft>
+                <a:spcPts val="200"/>
+              </a:spcAft>
+              <a:defRPr sz="1800" b="1">
                 <a:solidFill>
                   <a:srgbClr val="FFFFFF"/>
                 </a:solidFill>
@@ -3336,8 +3346,8 @@
         </p:nvSpPr>
         <p:spPr>
           <a:xfrm>
-            <a:off x="393192" y="2130552"/>
-            <a:ext cx="2032345" cy="658368"/>
+            <a:off x="347472" y="1984248"/>
+            <a:ext cx="2065263" cy="640080"/>
           </a:xfrm>
           <a:prstGeom prst="rect">
             <a:avLst/>
@@ -3351,7 +3361,10 @@
           <a:lstStyle/>
           <a:p>
             <a:pPr algn="ctr">
-              <a:defRPr sz="1200" b="0">
+              <a:spcAft>
+                <a:spcPts val="200"/>
+              </a:spcAft>
+              <a:defRPr sz="1100" b="0">
                 <a:solidFill>
                   <a:srgbClr val="B4BED2"/>
                 </a:solidFill>
@@ -3361,32 +3374,96 @@
             <a:r>
               <a:t>生于硅片，GPU 与 HBM</a:t>
             </a:r>
-            <a:br/>
+          </a:p>
+          <a:p>
+            <a:pPr algn="ctr">
+              <a:spcAft>
+                <a:spcPts val="200"/>
+              </a:spcAft>
+              <a:defRPr sz="1100" b="0">
+                <a:solidFill>
+                  <a:srgbClr val="B4BED2"/>
+                </a:solidFill>
+                <a:latin typeface="Microsoft YaHei"/>
+              </a:defRPr>
+            </a:pPr>
             <a:r>
               <a:t>驱动一切。</a:t>
             </a:r>
           </a:p>
         </p:txBody>
       </p:sp>
-      <p:sp>
-        <p:nvSpPr>
-          <p:cNvPr id="9" name="Oval 8"/>
+      <p:pic>
+        <p:nvPicPr>
+          <p:cNvPr id="9" name="Picture 8" descr="01-compute.png"/>
+          <p:cNvPicPr>
+            <a:picLocks noChangeAspect="1"/>
+          </p:cNvPicPr>
+          <p:nvPr/>
+        </p:nvPicPr>
+        <p:blipFill>
+          <a:blip r:embed="rId2"/>
+          <a:stretch>
+            <a:fillRect/>
+          </a:stretch>
+        </p:blipFill>
+        <p:spPr>
+          <a:xfrm>
+            <a:off x="1050919" y="2697480"/>
+            <a:ext cx="658368" cy="658368"/>
+          </a:xfrm>
+          <a:prstGeom prst="rect">
+            <a:avLst/>
+          </a:prstGeom>
+        </p:spPr>
+      </p:pic>
+      <p:pic>
+        <p:nvPicPr>
+          <p:cNvPr id="10" name="Picture 9" descr="01-compute.png"/>
+          <p:cNvPicPr>
+            <a:picLocks noChangeAspect="1"/>
+          </p:cNvPicPr>
+          <p:nvPr/>
+        </p:nvPicPr>
+        <p:blipFill>
+          <a:blip r:embed="rId3"/>
+          <a:stretch>
+            <a:fillRect/>
+          </a:stretch>
+        </p:blipFill>
+        <p:spPr>
+          <a:xfrm>
+            <a:off x="384048" y="3520440"/>
+            <a:ext cx="1992111" cy="1874519"/>
+          </a:xfrm>
+          <a:prstGeom prst="rect">
+            <a:avLst/>
+          </a:prstGeom>
+        </p:spPr>
+      </p:pic>
+      <p:sp>
+        <p:nvSpPr>
+          <p:cNvPr id="11" name="Rounded Rectangle 10"/>
           <p:cNvSpPr/>
           <p:nvPr/>
         </p:nvSpPr>
         <p:spPr>
           <a:xfrm>
-            <a:off x="1098468" y="2953512"/>
-            <a:ext cx="621792" cy="621792"/>
-          </a:xfrm>
-          <a:prstGeom prst="ellipse">
-            <a:avLst/>
+            <a:off x="2632191" y="1508760"/>
+            <a:ext cx="2211567" cy="4114800"/>
+          </a:xfrm>
+          <a:prstGeom prst="roundRect">
+            <a:avLst>
+              <a:gd name="adj" fmla="val 8000"/>
+            </a:avLst>
           </a:prstGeom>
           <a:solidFill>
-            <a:srgbClr val="3B82F6"/>
+            <a:srgbClr val="0E1C32"/>
           </a:solidFill>
-          <a:ln>
-            <a:noFill/>
+          <a:ln w="12700">
+            <a:solidFill>
+              <a:srgbClr val="1E375A"/>
+            </a:solidFill>
           </a:ln>
         </p:spPr>
         <p:style>
@@ -3413,14 +3490,14 @@
       </p:sp>
       <p:sp>
         <p:nvSpPr>
-          <p:cNvPr id="10" name="TextBox 9"/>
+          <p:cNvPr id="12" name="TextBox 11"/>
           <p:cNvSpPr txBox="1"/>
           <p:nvPr/>
         </p:nvSpPr>
         <p:spPr>
           <a:xfrm>
-            <a:off x="1098468" y="3044952"/>
-            <a:ext cx="621792" cy="438912"/>
+            <a:off x="2705343" y="1618488"/>
+            <a:ext cx="2065263" cy="365760"/>
           </a:xfrm>
           <a:prstGeom prst="rect">
             <a:avLst/>
@@ -3428,13 +3505,16 @@
           <a:noFill/>
         </p:spPr>
         <p:txBody>
-          <a:bodyPr wrap="square" anchor="ctr">
+          <a:bodyPr wrap="square" anchor="t">
             <a:spAutoFit/>
           </a:bodyPr>
           <a:lstStyle/>
           <a:p>
             <a:pPr algn="ctr">
-              <a:defRPr sz="2200" b="1">
+              <a:spcAft>
+                <a:spcPts val="200"/>
+              </a:spcAft>
+              <a:defRPr sz="1800" b="1">
                 <a:solidFill>
                   <a:srgbClr val="FFFFFF"/>
                 </a:solidFill>
@@ -3442,53 +3522,134 @@
               </a:defRPr>
             </a:pPr>
             <a:r>
-              <a:t>芯</a:t>
+              <a:t>基础设施层</a:t>
+            </a:r>
+          </a:p>
+        </p:txBody>
+      </p:sp>
+      <p:sp>
+        <p:nvSpPr>
+          <p:cNvPr id="13" name="TextBox 12"/>
+          <p:cNvSpPr txBox="1"/>
+          <p:nvPr/>
+        </p:nvSpPr>
+        <p:spPr>
+          <a:xfrm>
+            <a:off x="2705343" y="1984248"/>
+            <a:ext cx="2065263" cy="640080"/>
+          </a:xfrm>
+          <a:prstGeom prst="rect">
+            <a:avLst/>
+          </a:prstGeom>
+          <a:noFill/>
+        </p:spPr>
+        <p:txBody>
+          <a:bodyPr wrap="square" anchor="t">
+            <a:spAutoFit/>
+          </a:bodyPr>
+          <a:lstStyle/>
+          <a:p>
+            <a:pPr algn="ctr">
+              <a:spcAft>
+                <a:spcPts val="200"/>
+              </a:spcAft>
+              <a:defRPr sz="1100" b="0">
+                <a:solidFill>
+                  <a:srgbClr val="B4BED2"/>
+                </a:solidFill>
+                <a:latin typeface="Microsoft YaHei"/>
+              </a:defRPr>
+            </a:pPr>
+            <a:r>
+              <a:t>电力、液冷与万卡</a:t>
+            </a:r>
+          </a:p>
+          <a:p>
+            <a:pPr algn="ctr">
+              <a:spcAft>
+                <a:spcPts val="200"/>
+              </a:spcAft>
+              <a:defRPr sz="1100" b="0">
+                <a:solidFill>
+                  <a:srgbClr val="B4BED2"/>
+                </a:solidFill>
+                <a:latin typeface="Microsoft YaHei"/>
+              </a:defRPr>
+            </a:pPr>
+            <a:r>
+              <a:t>集群规模化。</a:t>
             </a:r>
           </a:p>
         </p:txBody>
       </p:sp>
       <p:pic>
         <p:nvPicPr>
-          <p:cNvPr id="11" name="Picture 10" descr="col-1.png"/>
+          <p:cNvPr id="14" name="Picture 13" descr="02-infra.png"/>
           <p:cNvPicPr>
             <a:picLocks noChangeAspect="1"/>
           </p:cNvPicPr>
           <p:nvPr/>
         </p:nvPicPr>
         <p:blipFill>
-          <a:blip r:embed="rId2"/>
+          <a:blip r:embed="rId4"/>
           <a:stretch>
             <a:fillRect/>
           </a:stretch>
         </p:blipFill>
         <p:spPr>
           <a:xfrm>
-            <a:off x="429768" y="3776472"/>
-            <a:ext cx="1959193" cy="1572768"/>
+            <a:off x="3408791" y="2697480"/>
+            <a:ext cx="658368" cy="658368"/>
           </a:xfrm>
           <a:prstGeom prst="rect">
             <a:avLst/>
           </a:prstGeom>
         </p:spPr>
       </p:pic>
-      <p:sp>
-        <p:nvSpPr>
-          <p:cNvPr id="12" name="Rounded Rectangle 11"/>
+      <p:pic>
+        <p:nvPicPr>
+          <p:cNvPr id="15" name="Picture 14" descr="02-infra.png"/>
+          <p:cNvPicPr>
+            <a:picLocks noChangeAspect="1"/>
+          </p:cNvPicPr>
+          <p:nvPr/>
+        </p:nvPicPr>
+        <p:blipFill>
+          <a:blip r:embed="rId5"/>
+          <a:stretch>
+            <a:fillRect/>
+          </a:stretch>
+        </p:blipFill>
+        <p:spPr>
+          <a:xfrm>
+            <a:off x="2741919" y="3520440"/>
+            <a:ext cx="1992111" cy="1874519"/>
+          </a:xfrm>
+          <a:prstGeom prst="rect">
+            <a:avLst/>
+          </a:prstGeom>
+        </p:spPr>
+      </p:pic>
+      <p:sp>
+        <p:nvSpPr>
+          <p:cNvPr id="16" name="Rounded Rectangle 15"/>
           <p:cNvSpPr/>
           <p:nvPr/>
         </p:nvSpPr>
         <p:spPr>
           <a:xfrm>
-            <a:off x="2663281" y="1600200"/>
-            <a:ext cx="2178649" cy="3977639"/>
+            <a:off x="4990063" y="1508760"/>
+            <a:ext cx="2211567" cy="4114800"/>
           </a:xfrm>
           <a:prstGeom prst="roundRect">
-            <a:avLst/>
+            <a:avLst>
+              <a:gd name="adj" fmla="val 8000"/>
+            </a:avLst>
           </a:prstGeom>
           <a:solidFill>
             <a:srgbClr val="0E1C32"/>
           </a:solidFill>
-          <a:ln>
+          <a:ln w="12700">
             <a:solidFill>
               <a:srgbClr val="1E375A"/>
             </a:solidFill>
@@ -3518,14 +3679,14 @@
       </p:sp>
       <p:sp>
         <p:nvSpPr>
-          <p:cNvPr id="13" name="TextBox 12"/>
+          <p:cNvPr id="17" name="TextBox 16"/>
           <p:cNvSpPr txBox="1"/>
           <p:nvPr/>
         </p:nvSpPr>
         <p:spPr>
           <a:xfrm>
-            <a:off x="2754721" y="1709928"/>
-            <a:ext cx="1995769" cy="384048"/>
+            <a:off x="5063215" y="1618488"/>
+            <a:ext cx="2065263" cy="365760"/>
           </a:xfrm>
           <a:prstGeom prst="rect">
             <a:avLst/>
@@ -3539,7 +3700,10 @@
           <a:lstStyle/>
           <a:p>
             <a:pPr algn="ctr">
-              <a:defRPr sz="2000" b="1">
+              <a:spcAft>
+                <a:spcPts val="200"/>
+              </a:spcAft>
+              <a:defRPr sz="1800" b="1">
                 <a:solidFill>
                   <a:srgbClr val="FFFFFF"/>
                 </a:solidFill>
@@ -3547,21 +3711,21 @@
               </a:defRPr>
             </a:pPr>
             <a:r>
-              <a:t>基础设施层</a:t>
-            </a:r>
-          </a:p>
-        </p:txBody>
-      </p:sp>
-      <p:sp>
-        <p:nvSpPr>
-          <p:cNvPr id="14" name="TextBox 13"/>
+              <a:t>模型层</a:t>
+            </a:r>
+          </a:p>
+        </p:txBody>
+      </p:sp>
+      <p:sp>
+        <p:nvSpPr>
+          <p:cNvPr id="18" name="TextBox 17"/>
           <p:cNvSpPr txBox="1"/>
           <p:nvPr/>
         </p:nvSpPr>
         <p:spPr>
           <a:xfrm>
-            <a:off x="2736433" y="2130552"/>
-            <a:ext cx="2032345" cy="658368"/>
+            <a:off x="5063215" y="1984248"/>
+            <a:ext cx="2065263" cy="640080"/>
           </a:xfrm>
           <a:prstGeom prst="rect">
             <a:avLst/>
@@ -3575,7 +3739,10 @@
           <a:lstStyle/>
           <a:p>
             <a:pPr algn="ctr">
-              <a:defRPr sz="1200" b="0">
+              <a:spcAft>
+                <a:spcPts val="200"/>
+              </a:spcAft>
+              <a:defRPr sz="1100" b="0">
                 <a:solidFill>
                   <a:srgbClr val="B4BED2"/>
                 </a:solidFill>
@@ -3583,34 +3750,98 @@
               </a:defRPr>
             </a:pPr>
             <a:r>
-              <a:t>电力、液冷与万卡</a:t>
-            </a:r>
-            <a:br/>
-            <a:r>
-              <a:t>集群规模化。</a:t>
-            </a:r>
-          </a:p>
-        </p:txBody>
-      </p:sp>
-      <p:sp>
-        <p:nvSpPr>
-          <p:cNvPr id="15" name="Oval 14"/>
+              <a:t>数据训练，算力炼成</a:t>
+            </a:r>
+          </a:p>
+          <a:p>
+            <a:pPr algn="ctr">
+              <a:spcAft>
+                <a:spcPts val="200"/>
+              </a:spcAft>
+              <a:defRPr sz="1100" b="0">
+                <a:solidFill>
+                  <a:srgbClr val="B4BED2"/>
+                </a:solidFill>
+                <a:latin typeface="Microsoft YaHei"/>
+              </a:defRPr>
+            </a:pPr>
+            <a:r>
+              <a:t>认知能力。</a:t>
+            </a:r>
+          </a:p>
+        </p:txBody>
+      </p:sp>
+      <p:pic>
+        <p:nvPicPr>
+          <p:cNvPr id="19" name="Picture 18" descr="03-model.png"/>
+          <p:cNvPicPr>
+            <a:picLocks noChangeAspect="1"/>
+          </p:cNvPicPr>
+          <p:nvPr/>
+        </p:nvPicPr>
+        <p:blipFill>
+          <a:blip r:embed="rId6"/>
+          <a:stretch>
+            <a:fillRect/>
+          </a:stretch>
+        </p:blipFill>
+        <p:spPr>
+          <a:xfrm>
+            <a:off x="5766663" y="2697480"/>
+            <a:ext cx="658368" cy="658368"/>
+          </a:xfrm>
+          <a:prstGeom prst="rect">
+            <a:avLst/>
+          </a:prstGeom>
+        </p:spPr>
+      </p:pic>
+      <p:pic>
+        <p:nvPicPr>
+          <p:cNvPr id="20" name="Picture 19" descr="03-model.png"/>
+          <p:cNvPicPr>
+            <a:picLocks noChangeAspect="1"/>
+          </p:cNvPicPr>
+          <p:nvPr/>
+        </p:nvPicPr>
+        <p:blipFill>
+          <a:blip r:embed="rId7"/>
+          <a:stretch>
+            <a:fillRect/>
+          </a:stretch>
+        </p:blipFill>
+        <p:spPr>
+          <a:xfrm>
+            <a:off x="5099791" y="3520440"/>
+            <a:ext cx="1992111" cy="1874519"/>
+          </a:xfrm>
+          <a:prstGeom prst="rect">
+            <a:avLst/>
+          </a:prstGeom>
+        </p:spPr>
+      </p:pic>
+      <p:sp>
+        <p:nvSpPr>
+          <p:cNvPr id="21" name="Rounded Rectangle 20"/>
           <p:cNvSpPr/>
           <p:nvPr/>
         </p:nvSpPr>
         <p:spPr>
           <a:xfrm>
-            <a:off x="3441709" y="2953512"/>
-            <a:ext cx="621792" cy="621792"/>
-          </a:xfrm>
-          <a:prstGeom prst="ellipse">
-            <a:avLst/>
+            <a:off x="7347935" y="1508760"/>
+            <a:ext cx="2211567" cy="4114800"/>
+          </a:xfrm>
+          <a:prstGeom prst="roundRect">
+            <a:avLst>
+              <a:gd name="adj" fmla="val 8000"/>
+            </a:avLst>
           </a:prstGeom>
           <a:solidFill>
-            <a:srgbClr val="3B82F6"/>
+            <a:srgbClr val="0E1C32"/>
           </a:solidFill>
-          <a:ln>
-            <a:noFill/>
+          <a:ln w="12700">
+            <a:solidFill>
+              <a:srgbClr val="1E375A"/>
+            </a:solidFill>
           </a:ln>
         </p:spPr>
         <p:style>
@@ -3637,14 +3868,14 @@
       </p:sp>
       <p:sp>
         <p:nvSpPr>
-          <p:cNvPr id="16" name="TextBox 15"/>
+          <p:cNvPr id="22" name="TextBox 21"/>
           <p:cNvSpPr txBox="1"/>
           <p:nvPr/>
         </p:nvSpPr>
         <p:spPr>
           <a:xfrm>
-            <a:off x="3441709" y="3044952"/>
-            <a:ext cx="621792" cy="438912"/>
+            <a:off x="7421087" y="1618488"/>
+            <a:ext cx="2065263" cy="365760"/>
           </a:xfrm>
           <a:prstGeom prst="rect">
             <a:avLst/>
@@ -3652,13 +3883,16 @@
           <a:noFill/>
         </p:spPr>
         <p:txBody>
-          <a:bodyPr wrap="square" anchor="ctr">
+          <a:bodyPr wrap="square" anchor="t">
             <a:spAutoFit/>
           </a:bodyPr>
           <a:lstStyle/>
           <a:p>
             <a:pPr algn="ctr">
-              <a:defRPr sz="2200" b="1">
+              <a:spcAft>
+                <a:spcPts val="200"/>
+              </a:spcAft>
+              <a:defRPr sz="1800" b="1">
                 <a:solidFill>
                   <a:srgbClr val="FFFFFF"/>
                 </a:solidFill>
@@ -3666,53 +3900,134 @@
               </a:defRPr>
             </a:pPr>
             <a:r>
-              <a:t>云</a:t>
+              <a:t>智能体层</a:t>
+            </a:r>
+          </a:p>
+        </p:txBody>
+      </p:sp>
+      <p:sp>
+        <p:nvSpPr>
+          <p:cNvPr id="23" name="TextBox 22"/>
+          <p:cNvSpPr txBox="1"/>
+          <p:nvPr/>
+        </p:nvSpPr>
+        <p:spPr>
+          <a:xfrm>
+            <a:off x="7421087" y="1984248"/>
+            <a:ext cx="2065263" cy="640080"/>
+          </a:xfrm>
+          <a:prstGeom prst="rect">
+            <a:avLst/>
+          </a:prstGeom>
+          <a:noFill/>
+        </p:spPr>
+        <p:txBody>
+          <a:bodyPr wrap="square" anchor="t">
+            <a:spAutoFit/>
+          </a:bodyPr>
+          <a:lstStyle/>
+          <a:p>
+            <a:pPr algn="ctr">
+              <a:spcAft>
+                <a:spcPts val="200"/>
+              </a:spcAft>
+              <a:defRPr sz="1100" b="0">
+                <a:solidFill>
+                  <a:srgbClr val="B4BED2"/>
+                </a:solidFill>
+                <a:latin typeface="Microsoft YaHei"/>
+              </a:defRPr>
+            </a:pPr>
+            <a:r>
+              <a:t>工具编排，自主规划</a:t>
+            </a:r>
+          </a:p>
+          <a:p>
+            <a:pPr algn="ctr">
+              <a:spcAft>
+                <a:spcPts val="200"/>
+              </a:spcAft>
+              <a:defRPr sz="1100" b="0">
+                <a:solidFill>
+                  <a:srgbClr val="B4BED2"/>
+                </a:solidFill>
+                <a:latin typeface="Microsoft YaHei"/>
+              </a:defRPr>
+            </a:pPr>
+            <a:r>
+              <a:t>与闭环执行。</a:t>
             </a:r>
           </a:p>
         </p:txBody>
       </p:sp>
       <p:pic>
         <p:nvPicPr>
-          <p:cNvPr id="17" name="Picture 16" descr="col-2.png"/>
+          <p:cNvPr id="24" name="Picture 23" descr="04-agent.png"/>
           <p:cNvPicPr>
             <a:picLocks noChangeAspect="1"/>
           </p:cNvPicPr>
           <p:nvPr/>
         </p:nvPicPr>
         <p:blipFill>
-          <a:blip r:embed="rId3"/>
+          <a:blip r:embed="rId8"/>
           <a:stretch>
             <a:fillRect/>
           </a:stretch>
         </p:blipFill>
         <p:spPr>
           <a:xfrm>
-            <a:off x="2773009" y="3776472"/>
-            <a:ext cx="1959193" cy="1572768"/>
+            <a:off x="8124535" y="2697480"/>
+            <a:ext cx="658368" cy="658368"/>
           </a:xfrm>
           <a:prstGeom prst="rect">
             <a:avLst/>
           </a:prstGeom>
         </p:spPr>
       </p:pic>
-      <p:sp>
-        <p:nvSpPr>
-          <p:cNvPr id="18" name="Rounded Rectangle 17"/>
+      <p:pic>
+        <p:nvPicPr>
+          <p:cNvPr id="25" name="Picture 24" descr="04-agent.png"/>
+          <p:cNvPicPr>
+            <a:picLocks noChangeAspect="1"/>
+          </p:cNvPicPr>
+          <p:nvPr/>
+        </p:nvPicPr>
+        <p:blipFill>
+          <a:blip r:embed="rId9"/>
+          <a:stretch>
+            <a:fillRect/>
+          </a:stretch>
+        </p:blipFill>
+        <p:spPr>
+          <a:xfrm>
+            <a:off x="7457663" y="3520440"/>
+            <a:ext cx="1992111" cy="1874519"/>
+          </a:xfrm>
+          <a:prstGeom prst="rect">
+            <a:avLst/>
+          </a:prstGeom>
+        </p:spPr>
+      </p:pic>
+      <p:sp>
+        <p:nvSpPr>
+          <p:cNvPr id="26" name="Rounded Rectangle 25"/>
           <p:cNvSpPr/>
           <p:nvPr/>
         </p:nvSpPr>
         <p:spPr>
           <a:xfrm>
-            <a:off x="5006522" y="1600200"/>
-            <a:ext cx="2178649" cy="3977639"/>
+            <a:off x="9705807" y="1508760"/>
+            <a:ext cx="2211567" cy="4114800"/>
           </a:xfrm>
           <a:prstGeom prst="roundRect">
-            <a:avLst/>
+            <a:avLst>
+              <a:gd name="adj" fmla="val 8000"/>
+            </a:avLst>
           </a:prstGeom>
           <a:solidFill>
             <a:srgbClr val="0E1C32"/>
           </a:solidFill>
-          <a:ln>
+          <a:ln w="12700">
             <a:solidFill>
               <a:srgbClr val="1E375A"/>
             </a:solidFill>
@@ -3742,14 +4057,14 @@
       </p:sp>
       <p:sp>
         <p:nvSpPr>
-          <p:cNvPr id="19" name="TextBox 18"/>
+          <p:cNvPr id="27" name="TextBox 26"/>
           <p:cNvSpPr txBox="1"/>
           <p:nvPr/>
         </p:nvSpPr>
         <p:spPr>
           <a:xfrm>
-            <a:off x="5097962" y="1709928"/>
-            <a:ext cx="1995769" cy="384048"/>
+            <a:off x="9778959" y="1618488"/>
+            <a:ext cx="2065263" cy="365760"/>
           </a:xfrm>
           <a:prstGeom prst="rect">
             <a:avLst/>
@@ -3763,7 +4078,10 @@
           <a:lstStyle/>
           <a:p>
             <a:pPr algn="ctr">
-              <a:defRPr sz="2000" b="1">
+              <a:spcAft>
+                <a:spcPts val="200"/>
+              </a:spcAft>
+              <a:defRPr sz="1800" b="1">
                 <a:solidFill>
                   <a:srgbClr val="FFFFFF"/>
                 </a:solidFill>
@@ -3771,21 +4089,21 @@
               </a:defRPr>
             </a:pPr>
             <a:r>
-              <a:t>模型层</a:t>
-            </a:r>
-          </a:p>
-        </p:txBody>
-      </p:sp>
-      <p:sp>
-        <p:nvSpPr>
-          <p:cNvPr id="20" name="TextBox 19"/>
+              <a:t>应用层</a:t>
+            </a:r>
+          </a:p>
+        </p:txBody>
+      </p:sp>
+      <p:sp>
+        <p:nvSpPr>
+          <p:cNvPr id="28" name="TextBox 27"/>
           <p:cNvSpPr txBox="1"/>
           <p:nvPr/>
         </p:nvSpPr>
         <p:spPr>
           <a:xfrm>
-            <a:off x="5079674" y="2130552"/>
-            <a:ext cx="2032345" cy="658368"/>
+            <a:off x="9778959" y="1984248"/>
+            <a:ext cx="2065263" cy="640080"/>
           </a:xfrm>
           <a:prstGeom prst="rect">
             <a:avLst/>
@@ -3799,7 +4117,10 @@
           <a:lstStyle/>
           <a:p>
             <a:pPr algn="ctr">
-              <a:defRPr sz="1200" b="0">
+              <a:spcAft>
+                <a:spcPts val="200"/>
+              </a:spcAft>
+              <a:defRPr sz="1100" b="0">
                 <a:solidFill>
                   <a:srgbClr val="B4BED2"/>
                 </a:solidFill>
@@ -3807,31 +4128,91 @@
               </a:defRPr>
             </a:pPr>
             <a:r>
-              <a:t>数据训练，算力炼成</a:t>
-            </a:r>
-            <a:br/>
-            <a:r>
-              <a:t>认知能力。</a:t>
-            </a:r>
-          </a:p>
-        </p:txBody>
-      </p:sp>
-      <p:sp>
-        <p:nvSpPr>
-          <p:cNvPr id="21" name="Oval 20"/>
+              <a:t>落地千行百业，</a:t>
+            </a:r>
+          </a:p>
+          <a:p>
+            <a:pPr algn="ctr">
+              <a:spcAft>
+                <a:spcPts val="200"/>
+              </a:spcAft>
+              <a:defRPr sz="1100" b="0">
+                <a:solidFill>
+                  <a:srgbClr val="B4BED2"/>
+                </a:solidFill>
+                <a:latin typeface="Microsoft YaHei"/>
+              </a:defRPr>
+            </a:pPr>
+            <a:r>
+              <a:t>嵌入日常工作。</a:t>
+            </a:r>
+          </a:p>
+        </p:txBody>
+      </p:sp>
+      <p:pic>
+        <p:nvPicPr>
+          <p:cNvPr id="29" name="Picture 28" descr="05-app.png"/>
+          <p:cNvPicPr>
+            <a:picLocks noChangeAspect="1"/>
+          </p:cNvPicPr>
+          <p:nvPr/>
+        </p:nvPicPr>
+        <p:blipFill>
+          <a:blip r:embed="rId10"/>
+          <a:stretch>
+            <a:fillRect/>
+          </a:stretch>
+        </p:blipFill>
+        <p:spPr>
+          <a:xfrm>
+            <a:off x="10482407" y="2697480"/>
+            <a:ext cx="658368" cy="658368"/>
+          </a:xfrm>
+          <a:prstGeom prst="rect">
+            <a:avLst/>
+          </a:prstGeom>
+        </p:spPr>
+      </p:pic>
+      <p:pic>
+        <p:nvPicPr>
+          <p:cNvPr id="30" name="Picture 29" descr="05-app.png"/>
+          <p:cNvPicPr>
+            <a:picLocks noChangeAspect="1"/>
+          </p:cNvPicPr>
+          <p:nvPr/>
+        </p:nvPicPr>
+        <p:blipFill>
+          <a:blip r:embed="rId11"/>
+          <a:stretch>
+            <a:fillRect/>
+          </a:stretch>
+        </p:blipFill>
+        <p:spPr>
+          <a:xfrm>
+            <a:off x="9815535" y="3520440"/>
+            <a:ext cx="1992111" cy="1874519"/>
+          </a:xfrm>
+          <a:prstGeom prst="rect">
+            <a:avLst/>
+          </a:prstGeom>
+        </p:spPr>
+      </p:pic>
+      <p:sp>
+        <p:nvSpPr>
+          <p:cNvPr id="31" name="Rectangle 30"/>
           <p:cNvSpPr/>
           <p:nvPr/>
         </p:nvSpPr>
         <p:spPr>
           <a:xfrm>
-            <a:off x="5784950" y="2953512"/>
-            <a:ext cx="621792" cy="621792"/>
-          </a:xfrm>
-          <a:prstGeom prst="ellipse">
+            <a:off x="0" y="5806440"/>
+            <a:ext cx="12191695" cy="960120"/>
+          </a:xfrm>
+          <a:prstGeom prst="rect">
             <a:avLst/>
           </a:prstGeom>
           <a:solidFill>
-            <a:srgbClr val="3B82F6"/>
+            <a:srgbClr val="12233C"/>
           </a:solidFill>
           <a:ln>
             <a:noFill/>
@@ -3861,14 +4242,14 @@
       </p:sp>
       <p:sp>
         <p:nvSpPr>
-          <p:cNvPr id="22" name="TextBox 21"/>
+          <p:cNvPr id="32" name="TextBox 31"/>
           <p:cNvSpPr txBox="1"/>
           <p:nvPr/>
         </p:nvSpPr>
         <p:spPr>
           <a:xfrm>
-            <a:off x="5784950" y="3044952"/>
-            <a:ext cx="621792" cy="438912"/>
+            <a:off x="365760" y="6062472"/>
+            <a:ext cx="6217920" cy="502920"/>
           </a:xfrm>
           <a:prstGeom prst="rect">
             <a:avLst/>
@@ -3876,43 +4257,50 @@
           <a:noFill/>
         </p:spPr>
         <p:txBody>
-          <a:bodyPr wrap="square" anchor="ctr">
+          <a:bodyPr wrap="none" anchor="ctr">
             <a:spAutoFit/>
           </a:bodyPr>
           <a:lstStyle/>
           <a:p>
-            <a:pPr algn="ctr">
-              <a:defRPr sz="2200" b="1">
+            <a:r>
+              <a:rPr sz="1400">
                 <a:solidFill>
                   <a:srgbClr val="FFFFFF"/>
                 </a:solidFill>
                 <a:latin typeface="Microsoft YaHei"/>
-              </a:defRPr>
-            </a:pPr>
-            <a:r>
-              <a:t>脑</a:t>
+              </a:rPr>
+              <a:t>同一技术，不同层级。</a:t>
+            </a:r>
+            <a:r>
+              <a:rPr sz="1400" b="1">
+                <a:solidFill>
+                  <a:srgbClr val="F5C518"/>
+                </a:solidFill>
+                <a:latin typeface="Microsoft YaHei"/>
+              </a:rPr>
+              <a:t>看懂产业链，才能抓住价值。</a:t>
             </a:r>
           </a:p>
         </p:txBody>
       </p:sp>
       <p:pic>
         <p:nvPicPr>
-          <p:cNvPr id="23" name="Picture 22" descr="col-3.png"/>
+          <p:cNvPr id="33" name="Picture 32" descr="01-capex.png"/>
           <p:cNvPicPr>
             <a:picLocks noChangeAspect="1"/>
           </p:cNvPicPr>
           <p:nvPr/>
         </p:nvPicPr>
         <p:blipFill>
-          <a:blip r:embed="rId4"/>
+          <a:blip r:embed="rId12"/>
           <a:stretch>
             <a:fillRect/>
           </a:stretch>
         </p:blipFill>
         <p:spPr>
           <a:xfrm>
-            <a:off x="5116250" y="3776472"/>
-            <a:ext cx="1959193" cy="1572768"/>
+            <a:off x="7315200" y="5916168"/>
+            <a:ext cx="365760" cy="365760"/>
           </a:xfrm>
           <a:prstGeom prst="rect">
             <a:avLst/>
@@ -3921,59 +4309,14 @@
       </p:pic>
       <p:sp>
         <p:nvSpPr>
-          <p:cNvPr id="24" name="Rounded Rectangle 23"/>
-          <p:cNvSpPr/>
-          <p:nvPr/>
-        </p:nvSpPr>
-        <p:spPr>
-          <a:xfrm>
-            <a:off x="7349763" y="1600200"/>
-            <a:ext cx="2178649" cy="3977639"/>
-          </a:xfrm>
-          <a:prstGeom prst="roundRect">
-            <a:avLst/>
-          </a:prstGeom>
-          <a:solidFill>
-            <a:srgbClr val="0E1C32"/>
-          </a:solidFill>
-          <a:ln>
-            <a:solidFill>
-              <a:srgbClr val="1E375A"/>
-            </a:solidFill>
-          </a:ln>
-        </p:spPr>
-        <p:style>
-          <a:lnRef idx="1">
-            <a:schemeClr val="accent1"/>
-          </a:lnRef>
-          <a:fillRef idx="3">
-            <a:schemeClr val="accent1"/>
-          </a:fillRef>
-          <a:effectRef idx="2">
-            <a:schemeClr val="accent1"/>
-          </a:effectRef>
-          <a:fontRef idx="minor">
-            <a:schemeClr val="lt1"/>
-          </a:fontRef>
-        </p:style>
-        <p:txBody>
-          <a:bodyPr rtlCol="0" anchor="ctr"/>
-          <a:lstStyle/>
-          <a:p>
-            <a:pPr algn="ctr"/>
-          </a:p>
-        </p:txBody>
-      </p:sp>
-      <p:sp>
-        <p:nvSpPr>
-          <p:cNvPr id="25" name="TextBox 24"/>
+          <p:cNvPr id="34" name="TextBox 33"/>
           <p:cNvSpPr txBox="1"/>
           <p:nvPr/>
         </p:nvSpPr>
         <p:spPr>
           <a:xfrm>
-            <a:off x="7441203" y="1709928"/>
-            <a:ext cx="1995769" cy="384048"/>
+            <a:off x="6949440" y="6327648"/>
+            <a:ext cx="1188720" cy="320040"/>
           </a:xfrm>
           <a:prstGeom prst="rect">
             <a:avLst/>
@@ -3987,43 +4330,10 @@
           <a:lstStyle/>
           <a:p>
             <a:pPr algn="ctr">
-              <a:defRPr sz="2000" b="1">
-                <a:solidFill>
-                  <a:srgbClr val="FFFFFF"/>
-                </a:solidFill>
-                <a:latin typeface="Microsoft YaHei"/>
-              </a:defRPr>
-            </a:pPr>
-            <a:r>
-              <a:t>智能体层</a:t>
-            </a:r>
-          </a:p>
-        </p:txBody>
-      </p:sp>
-      <p:sp>
-        <p:nvSpPr>
-          <p:cNvPr id="26" name="TextBox 25"/>
-          <p:cNvSpPr txBox="1"/>
-          <p:nvPr/>
-        </p:nvSpPr>
-        <p:spPr>
-          <a:xfrm>
-            <a:off x="7422915" y="2130552"/>
-            <a:ext cx="2032345" cy="658368"/>
-          </a:xfrm>
-          <a:prstGeom prst="rect">
-            <a:avLst/>
-          </a:prstGeom>
-          <a:noFill/>
-        </p:spPr>
-        <p:txBody>
-          <a:bodyPr wrap="square" anchor="t">
-            <a:spAutoFit/>
-          </a:bodyPr>
-          <a:lstStyle/>
-          <a:p>
-            <a:pPr algn="ctr">
-              <a:defRPr sz="1200" b="0">
+              <a:spcAft>
+                <a:spcPts val="200"/>
+              </a:spcAft>
+              <a:defRPr sz="1100" b="0">
                 <a:solidFill>
                   <a:srgbClr val="B4BED2"/>
                 </a:solidFill>
@@ -4031,112 +4341,29 @@
               </a:defRPr>
             </a:pPr>
             <a:r>
-              <a:t>工具编排，自主规划</a:t>
-            </a:r>
-            <a:br/>
-            <a:r>
-              <a:t>与闭环执行。</a:t>
-            </a:r>
-          </a:p>
-        </p:txBody>
-      </p:sp>
-      <p:sp>
-        <p:nvSpPr>
-          <p:cNvPr id="27" name="Oval 26"/>
-          <p:cNvSpPr/>
-          <p:nvPr/>
-        </p:nvSpPr>
-        <p:spPr>
-          <a:xfrm>
-            <a:off x="8128191" y="2953512"/>
-            <a:ext cx="621792" cy="621792"/>
-          </a:xfrm>
-          <a:prstGeom prst="ellipse">
-            <a:avLst/>
-          </a:prstGeom>
-          <a:solidFill>
-            <a:srgbClr val="3B82F6"/>
-          </a:solidFill>
-          <a:ln>
-            <a:noFill/>
-          </a:ln>
-        </p:spPr>
-        <p:style>
-          <a:lnRef idx="1">
-            <a:schemeClr val="accent1"/>
-          </a:lnRef>
-          <a:fillRef idx="3">
-            <a:schemeClr val="accent1"/>
-          </a:fillRef>
-          <a:effectRef idx="2">
-            <a:schemeClr val="accent1"/>
-          </a:effectRef>
-          <a:fontRef idx="minor">
-            <a:schemeClr val="lt1"/>
-          </a:fontRef>
-        </p:style>
-        <p:txBody>
-          <a:bodyPr rtlCol="0" anchor="ctr"/>
-          <a:lstStyle/>
-          <a:p>
-            <a:pPr algn="ctr"/>
-          </a:p>
-        </p:txBody>
-      </p:sp>
-      <p:sp>
-        <p:nvSpPr>
-          <p:cNvPr id="28" name="TextBox 27"/>
-          <p:cNvSpPr txBox="1"/>
-          <p:nvPr/>
-        </p:nvSpPr>
-        <p:spPr>
-          <a:xfrm>
-            <a:off x="8128191" y="3044952"/>
-            <a:ext cx="621792" cy="438912"/>
-          </a:xfrm>
-          <a:prstGeom prst="rect">
-            <a:avLst/>
-          </a:prstGeom>
-          <a:noFill/>
-        </p:spPr>
-        <p:txBody>
-          <a:bodyPr wrap="square" anchor="ctr">
-            <a:spAutoFit/>
-          </a:bodyPr>
-          <a:lstStyle/>
-          <a:p>
-            <a:pPr algn="ctr">
-              <a:defRPr sz="2200" b="1">
-                <a:solidFill>
-                  <a:srgbClr val="FFFFFF"/>
-                </a:solidFill>
-                <a:latin typeface="Microsoft YaHei"/>
-              </a:defRPr>
-            </a:pPr>
-            <a:r>
-              <a:t>链</a:t>
+              <a:t>资本开支</a:t>
             </a:r>
           </a:p>
         </p:txBody>
       </p:sp>
       <p:pic>
         <p:nvPicPr>
-          <p:cNvPr id="29" name="Picture 28" descr="col-4.png"/>
+          <p:cNvPr id="35" name="Picture 34" descr="02-latency.png"/>
           <p:cNvPicPr>
             <a:picLocks noChangeAspect="1"/>
           </p:cNvPicPr>
           <p:nvPr/>
         </p:nvPicPr>
         <p:blipFill>
-          <a:blip r:embed="rId5"/>
+          <a:blip r:embed="rId13"/>
           <a:stretch>
             <a:fillRect/>
           </a:stretch>
         </p:blipFill>
         <p:spPr>
           <a:xfrm>
-            <a:off x="7459491" y="3776472"/>
-            <a:ext cx="1959193" cy="1572768"/>
+            <a:off x="8641080" y="5916168"/>
+            <a:ext cx="365760" cy="365760"/>
           </a:xfrm>
           <a:prstGeom prst="rect">
             <a:avLst/>
@@ -4145,59 +4372,14 @@
       </p:pic>
       <p:sp>
         <p:nvSpPr>
-          <p:cNvPr id="30" name="Rounded Rectangle 29"/>
-          <p:cNvSpPr/>
-          <p:nvPr/>
-        </p:nvSpPr>
-        <p:spPr>
-          <a:xfrm>
-            <a:off x="9693004" y="1600200"/>
-            <a:ext cx="2178649" cy="3977639"/>
-          </a:xfrm>
-          <a:prstGeom prst="roundRect">
-            <a:avLst/>
-          </a:prstGeom>
-          <a:solidFill>
-            <a:srgbClr val="0E1C32"/>
-          </a:solidFill>
-          <a:ln>
-            <a:solidFill>
-              <a:srgbClr val="1E375A"/>
-            </a:solidFill>
-          </a:ln>
-        </p:spPr>
-        <p:style>
-          <a:lnRef idx="1">
-            <a:schemeClr val="accent1"/>
-          </a:lnRef>
-          <a:fillRef idx="3">
-            <a:schemeClr val="accent1"/>
-          </a:fillRef>
-          <a:effectRef idx="2">
-            <a:schemeClr val="accent1"/>
-          </a:effectRef>
-          <a:fontRef idx="minor">
-            <a:schemeClr val="lt1"/>
-          </a:fontRef>
-        </p:style>
-        <p:txBody>
-          <a:bodyPr rtlCol="0" anchor="ctr"/>
-          <a:lstStyle/>
-          <a:p>
-            <a:pPr algn="ctr"/>
-          </a:p>
-        </p:txBody>
-      </p:sp>
-      <p:sp>
-        <p:nvSpPr>
-          <p:cNvPr id="31" name="TextBox 30"/>
+          <p:cNvPr id="36" name="TextBox 35"/>
           <p:cNvSpPr txBox="1"/>
           <p:nvPr/>
         </p:nvSpPr>
         <p:spPr>
           <a:xfrm>
-            <a:off x="9784444" y="1709928"/>
-            <a:ext cx="1995769" cy="384048"/>
+            <a:off x="8275320" y="6327648"/>
+            <a:ext cx="1188720" cy="320040"/>
           </a:xfrm>
           <a:prstGeom prst="rect">
             <a:avLst/>
@@ -4211,43 +4393,10 @@
           <a:lstStyle/>
           <a:p>
             <a:pPr algn="ctr">
-              <a:defRPr sz="2000" b="1">
-                <a:solidFill>
-                  <a:srgbClr val="FFFFFF"/>
-                </a:solidFill>
-                <a:latin typeface="Microsoft YaHei"/>
-              </a:defRPr>
-            </a:pPr>
-            <a:r>
-              <a:t>应用层</a:t>
-            </a:r>
-          </a:p>
-        </p:txBody>
-      </p:sp>
-      <p:sp>
-        <p:nvSpPr>
-          <p:cNvPr id="32" name="TextBox 31"/>
-          <p:cNvSpPr txBox="1"/>
-          <p:nvPr/>
-        </p:nvSpPr>
-        <p:spPr>
-          <a:xfrm>
-            <a:off x="9766156" y="2130552"/>
-            <a:ext cx="2032345" cy="658368"/>
-          </a:xfrm>
-          <a:prstGeom prst="rect">
-            <a:avLst/>
-          </a:prstGeom>
-          <a:noFill/>
-        </p:spPr>
-        <p:txBody>
-          <a:bodyPr wrap="square" anchor="t">
-            <a:spAutoFit/>
-          </a:bodyPr>
-          <a:lstStyle/>
-          <a:p>
-            <a:pPr algn="ctr">
-              <a:defRPr sz="1200" b="0">
+              <a:spcAft>
+                <a:spcPts val="200"/>
+              </a:spcAft>
+              <a:defRPr sz="1100" b="0">
                 <a:solidFill>
                   <a:srgbClr val="B4BED2"/>
                 </a:solidFill>
@@ -4255,112 +4404,29 @@
               </a:defRPr>
             </a:pPr>
             <a:r>
-              <a:t>落地千行百业，</a:t>
-            </a:r>
-            <a:br/>
-            <a:r>
-              <a:t>嵌入日常工作。</a:t>
-            </a:r>
-          </a:p>
-        </p:txBody>
-      </p:sp>
-      <p:sp>
-        <p:nvSpPr>
-          <p:cNvPr id="33" name="Oval 32"/>
-          <p:cNvSpPr/>
-          <p:nvPr/>
-        </p:nvSpPr>
-        <p:spPr>
-          <a:xfrm>
-            <a:off x="10471432" y="2953512"/>
-            <a:ext cx="621792" cy="621792"/>
-          </a:xfrm>
-          <a:prstGeom prst="ellipse">
-            <a:avLst/>
-          </a:prstGeom>
-          <a:solidFill>
-            <a:srgbClr val="3B82F6"/>
-          </a:solidFill>
-          <a:ln>
-            <a:noFill/>
-          </a:ln>
-        </p:spPr>
-        <p:style>
-          <a:lnRef idx="1">
-            <a:schemeClr val="accent1"/>
-          </a:lnRef>
-          <a:fillRef idx="3">
-            <a:schemeClr val="accent1"/>
-          </a:fillRef>
-          <a:effectRef idx="2">
-            <a:schemeClr val="accent1"/>
-          </a:effectRef>
-          <a:fontRef idx="minor">
-            <a:schemeClr val="lt1"/>
-          </a:fontRef>
-        </p:style>
-        <p:txBody>
-          <a:bodyPr rtlCol="0" anchor="ctr"/>
-          <a:lstStyle/>
-          <a:p>
-            <a:pPr algn="ctr"/>
-          </a:p>
-        </p:txBody>
-      </p:sp>
-      <p:sp>
-        <p:nvSpPr>
-          <p:cNvPr id="34" name="TextBox 33"/>
-          <p:cNvSpPr txBox="1"/>
-          <p:nvPr/>
-        </p:nvSpPr>
-        <p:spPr>
-          <a:xfrm>
-            <a:off x="10471432" y="3044952"/>
-            <a:ext cx="621792" cy="438912"/>
-          </a:xfrm>
-          <a:prstGeom prst="rect">
-            <a:avLst/>
-          </a:prstGeom>
-          <a:noFill/>
-        </p:spPr>
-        <p:txBody>
-          <a:bodyPr wrap="square" anchor="ctr">
-            <a:spAutoFit/>
-          </a:bodyPr>
-          <a:lstStyle/>
-          <a:p>
-            <a:pPr algn="ctr">
-              <a:defRPr sz="2200" b="1">
-                <a:solidFill>
-                  <a:srgbClr val="FFFFFF"/>
-                </a:solidFill>
-                <a:latin typeface="Microsoft YaHei"/>
-              </a:defRPr>
-            </a:pPr>
-            <a:r>
-              <a:t>用</a:t>
+              <a:t>推理延迟</a:t>
             </a:r>
           </a:p>
         </p:txBody>
       </p:sp>
       <p:pic>
         <p:nvPicPr>
-          <p:cNvPr id="35" name="Picture 34" descr="col-5.png"/>
+          <p:cNvPr id="37" name="Picture 36" descr="03-unit.png"/>
           <p:cNvPicPr>
             <a:picLocks noChangeAspect="1"/>
           </p:cNvPicPr>
           <p:nvPr/>
         </p:nvPicPr>
         <p:blipFill>
-          <a:blip r:embed="rId6"/>
+          <a:blip r:embed="rId14"/>
           <a:stretch>
             <a:fillRect/>
           </a:stretch>
         </p:blipFill>
         <p:spPr>
           <a:xfrm>
-            <a:off x="9802732" y="3776472"/>
-            <a:ext cx="1959193" cy="1572768"/>
+            <a:off x="9966960" y="5916168"/>
+            <a:ext cx="365760" cy="365760"/>
           </a:xfrm>
           <a:prstGeom prst="rect">
             <a:avLst/>
@@ -4369,57 +4435,14 @@
       </p:pic>
       <p:sp>
         <p:nvSpPr>
-          <p:cNvPr id="36" name="Rectangle 35"/>
-          <p:cNvSpPr/>
-          <p:nvPr/>
-        </p:nvSpPr>
-        <p:spPr>
-          <a:xfrm>
-            <a:off x="0" y="5806440"/>
-            <a:ext cx="12191695" cy="960120"/>
-          </a:xfrm>
-          <a:prstGeom prst="rect">
-            <a:avLst/>
-          </a:prstGeom>
-          <a:solidFill>
-            <a:srgbClr val="12233C"/>
-          </a:solidFill>
-          <a:ln>
-            <a:noFill/>
-          </a:ln>
-        </p:spPr>
-        <p:style>
-          <a:lnRef idx="1">
-            <a:schemeClr val="accent1"/>
-          </a:lnRef>
-          <a:fillRef idx="3">
-            <a:schemeClr val="accent1"/>
-          </a:fillRef>
-          <a:effectRef idx="2">
-            <a:schemeClr val="accent1"/>
-          </a:effectRef>
-          <a:fontRef idx="minor">
-            <a:schemeClr val="lt1"/>
-          </a:fontRef>
-        </p:style>
-        <p:txBody>
-          <a:bodyPr rtlCol="0" anchor="ctr"/>
-          <a:lstStyle/>
-          <a:p>
-            <a:pPr algn="ctr"/>
-          </a:p>
-        </p:txBody>
-      </p:sp>
-      <p:sp>
-        <p:nvSpPr>
-          <p:cNvPr id="37" name="TextBox 36"/>
+          <p:cNvPr id="38" name="TextBox 37"/>
           <p:cNvSpPr txBox="1"/>
           <p:nvPr/>
         </p:nvSpPr>
         <p:spPr>
           <a:xfrm>
-            <a:off x="411480" y="6062472"/>
-            <a:ext cx="6400800" cy="502920"/>
+            <a:off x="9601200" y="6327648"/>
+            <a:ext cx="1188720" cy="320040"/>
           </a:xfrm>
           <a:prstGeom prst="rect">
             <a:avLst/>
@@ -4427,441 +4450,16 @@
           <a:noFill/>
         </p:spPr>
         <p:txBody>
-          <a:bodyPr wrap="none" anchor="ctr">
-            <a:spAutoFit/>
-          </a:bodyPr>
-          <a:lstStyle/>
-          <a:p>
-            <a:r>
-              <a:rPr sz="1500">
-                <a:solidFill>
-                  <a:srgbClr val="FFFFFF"/>
-                </a:solidFill>
-                <a:latin typeface="Microsoft YaHei"/>
-              </a:rPr>
-              <a:t>同一技术，不同层级。</a:t>
-            </a:r>
-            <a:r>
-              <a:rPr sz="1500" b="1">
-                <a:solidFill>
-                  <a:srgbClr val="F5C518"/>
-                </a:solidFill>
-                <a:latin typeface="Microsoft YaHei"/>
-              </a:rPr>
-              <a:t>看懂产业链，才能抓住价值。</a:t>
-            </a:r>
-          </a:p>
-        </p:txBody>
-      </p:sp>
-      <p:sp>
-        <p:nvSpPr>
-          <p:cNvPr id="38" name="Oval 37"/>
-          <p:cNvSpPr/>
-          <p:nvPr/>
-        </p:nvSpPr>
-        <p:spPr>
-          <a:xfrm>
-            <a:off x="7406640" y="5971032"/>
-            <a:ext cx="384048" cy="384048"/>
-          </a:xfrm>
-          <a:prstGeom prst="ellipse">
-            <a:avLst/>
-          </a:prstGeom>
-          <a:solidFill>
-            <a:srgbClr val="1E375A"/>
-          </a:solidFill>
-          <a:ln>
-            <a:solidFill>
-              <a:srgbClr val="3B82F6"/>
-            </a:solidFill>
-          </a:ln>
-        </p:spPr>
-        <p:style>
-          <a:lnRef idx="1">
-            <a:schemeClr val="accent1"/>
-          </a:lnRef>
-          <a:fillRef idx="3">
-            <a:schemeClr val="accent1"/>
-          </a:fillRef>
-          <a:effectRef idx="2">
-            <a:schemeClr val="accent1"/>
-          </a:effectRef>
-          <a:fontRef idx="minor">
-            <a:schemeClr val="lt1"/>
-          </a:fontRef>
-        </p:style>
-        <p:txBody>
-          <a:bodyPr rtlCol="0" anchor="ctr"/>
-          <a:lstStyle/>
-          <a:p>
-            <a:pPr algn="ctr"/>
-          </a:p>
-        </p:txBody>
-      </p:sp>
-      <p:sp>
-        <p:nvSpPr>
-          <p:cNvPr id="39" name="TextBox 38"/>
-          <p:cNvSpPr txBox="1"/>
-          <p:nvPr/>
-        </p:nvSpPr>
-        <p:spPr>
-          <a:xfrm>
-            <a:off x="7360920" y="6391656"/>
-            <a:ext cx="1234440" cy="320040"/>
-          </a:xfrm>
-          <a:prstGeom prst="rect">
-            <a:avLst/>
-          </a:prstGeom>
-          <a:noFill/>
-        </p:spPr>
-        <p:txBody>
           <a:bodyPr wrap="square" anchor="t">
             <a:spAutoFit/>
           </a:bodyPr>
           <a:lstStyle/>
           <a:p>
             <a:pPr algn="ctr">
+              <a:spcAft>
+                <a:spcPts val="200"/>
+              </a:spcAft>
               <a:defRPr sz="1100" b="0">
-                <a:solidFill>
-                  <a:srgbClr val="FFFFFF"/>
-                </a:solidFill>
-                <a:latin typeface="Microsoft YaHei"/>
-              </a:defRPr>
-            </a:pPr>
-            <a:r>
-              <a:t>资本开支</a:t>
-            </a:r>
-          </a:p>
-        </p:txBody>
-      </p:sp>
-      <p:sp>
-        <p:nvSpPr>
-          <p:cNvPr id="40" name="Oval 39"/>
-          <p:cNvSpPr/>
-          <p:nvPr/>
-        </p:nvSpPr>
-        <p:spPr>
-          <a:xfrm>
-            <a:off x="8869680" y="5971032"/>
-            <a:ext cx="384048" cy="384048"/>
-          </a:xfrm>
-          <a:prstGeom prst="ellipse">
-            <a:avLst/>
-          </a:prstGeom>
-          <a:solidFill>
-            <a:srgbClr val="1E375A"/>
-          </a:solidFill>
-          <a:ln>
-            <a:solidFill>
-              <a:srgbClr val="3B82F6"/>
-            </a:solidFill>
-          </a:ln>
-        </p:spPr>
-        <p:style>
-          <a:lnRef idx="1">
-            <a:schemeClr val="accent1"/>
-          </a:lnRef>
-          <a:fillRef idx="3">
-            <a:schemeClr val="accent1"/>
-          </a:fillRef>
-          <a:effectRef idx="2">
-            <a:schemeClr val="accent1"/>
-          </a:effectRef>
-          <a:fontRef idx="minor">
-            <a:schemeClr val="lt1"/>
-          </a:fontRef>
-        </p:style>
-        <p:txBody>
-          <a:bodyPr rtlCol="0" anchor="ctr"/>
-          <a:lstStyle/>
-          <a:p>
-            <a:pPr algn="ctr"/>
-          </a:p>
-        </p:txBody>
-      </p:sp>
-      <p:sp>
-        <p:nvSpPr>
-          <p:cNvPr id="41" name="TextBox 40"/>
-          <p:cNvSpPr txBox="1"/>
-          <p:nvPr/>
-        </p:nvSpPr>
-        <p:spPr>
-          <a:xfrm>
-            <a:off x="8823960" y="6391656"/>
-            <a:ext cx="1234440" cy="320040"/>
-          </a:xfrm>
-          <a:prstGeom prst="rect">
-            <a:avLst/>
-          </a:prstGeom>
-          <a:noFill/>
-        </p:spPr>
-        <p:txBody>
-          <a:bodyPr wrap="square" anchor="t">
-            <a:spAutoFit/>
-          </a:bodyPr>
-          <a:lstStyle/>
-          <a:p>
-            <a:pPr algn="ctr">
-              <a:defRPr sz="1100" b="0">
-                <a:solidFill>
-                  <a:srgbClr val="FFFFFF"/>
-                </a:solidFill>
-                <a:latin typeface="Microsoft YaHei"/>
-              </a:defRPr>
-            </a:pPr>
-            <a:r>
-              <a:t>推理延迟</a:t>
-            </a:r>
-          </a:p>
-        </p:txBody>
-      </p:sp>
-      <p:sp>
-        <p:nvSpPr>
-          <p:cNvPr id="42" name="Oval 41"/>
-          <p:cNvSpPr/>
-          <p:nvPr/>
-        </p:nvSpPr>
-        <p:spPr>
-          <a:xfrm>
-            <a:off x="10332720" y="5971032"/>
-            <a:ext cx="384048" cy="384048"/>
-          </a:xfrm>
-          <a:prstGeom prst="ellipse">
-            <a:avLst/>
-          </a:prstGeom>
-          <a:solidFill>
-            <a:srgbClr val="1E375A"/>
-          </a:solidFill>
-          <a:ln>
-            <a:solidFill>
-              <a:srgbClr val="3B82F6"/>
-            </a:solidFill>
-          </a:ln>
-        </p:spPr>
-        <p:style>
-          <a:lnRef idx="1">
-            <a:schemeClr val="accent1"/>
-          </a:lnRef>
-          <a:fillRef idx="3">
-            <a:schemeClr val="accent1"/>
-          </a:fillRef>
-          <a:effectRef idx="2">
-            <a:schemeClr val="accent1"/>
-          </a:effectRef>
-          <a:fontRef idx="minor">
-            <a:schemeClr val="lt1"/>
-          </a:fontRef>
-        </p:style>
-        <p:txBody>
-          <a:bodyPr rtlCol="0" anchor="ctr"/>
-          <a:lstStyle/>
-          <a:p>
-            <a:pPr algn="ctr"/>
-          </a:p>
-        </p:txBody>
-      </p:sp>
-      <p:sp>
-        <p:nvSpPr>
-          <p:cNvPr id="43" name="TextBox 42"/>
-          <p:cNvSpPr txBox="1"/>
-          <p:nvPr/>
-        </p:nvSpPr>
-        <p:spPr>
-          <a:xfrm>
-            <a:off x="10287000" y="6391656"/>
-            <a:ext cx="1234440" cy="320040"/>
-          </a:xfrm>
-          <a:prstGeom prst="rect">
-            <a:avLst/>
-          </a:prstGeom>
-          <a:noFill/>
-        </p:spPr>
-        <p:txBody>
-          <a:bodyPr wrap="square" anchor="t">
-            <a:spAutoFit/>
-          </a:bodyPr>
-          <a:lstStyle/>
-          <a:p>
-            <a:pPr algn="ctr">
-              <a:defRPr sz="1100" b="0">
-                <a:solidFill>
-                  <a:srgbClr val="FFFFFF"/>
-                </a:solidFill>
-                <a:latin typeface="Microsoft YaHei"/>
-              </a:defRPr>
-            </a:pPr>
-            <a:r>
-              <a:t>单位经济</a:t>
-            </a:r>
-          </a:p>
-        </p:txBody>
-      </p:sp>
-      <p:sp>
-        <p:nvSpPr>
-          <p:cNvPr id="44" name="Oval 43"/>
-          <p:cNvSpPr/>
-          <p:nvPr/>
-        </p:nvSpPr>
-        <p:spPr>
-          <a:xfrm>
-            <a:off x="11795760" y="5971032"/>
-            <a:ext cx="384048" cy="384048"/>
-          </a:xfrm>
-          <a:prstGeom prst="ellipse">
-            <a:avLst/>
-          </a:prstGeom>
-          <a:solidFill>
-            <a:srgbClr val="1E375A"/>
-          </a:solidFill>
-          <a:ln>
-            <a:solidFill>
-              <a:srgbClr val="3B82F6"/>
-            </a:solidFill>
-          </a:ln>
-        </p:spPr>
-        <p:style>
-          <a:lnRef idx="1">
-            <a:schemeClr val="accent1"/>
-          </a:lnRef>
-          <a:fillRef idx="3">
-            <a:schemeClr val="accent1"/>
-          </a:fillRef>
-          <a:effectRef idx="2">
-            <a:schemeClr val="accent1"/>
-          </a:effectRef>
-          <a:fontRef idx="minor">
-            <a:schemeClr val="lt1"/>
-          </a:fontRef>
-        </p:style>
-        <p:txBody>
-          <a:bodyPr rtlCol="0" anchor="ctr"/>
-          <a:lstStyle/>
-          <a:p>
-            <a:pPr algn="ctr"/>
-          </a:p>
-        </p:txBody>
-      </p:sp>
-      <p:sp>
-        <p:nvSpPr>
-          <p:cNvPr id="45" name="TextBox 44"/>
-          <p:cNvSpPr txBox="1"/>
-          <p:nvPr/>
-        </p:nvSpPr>
-        <p:spPr>
-          <a:xfrm>
-            <a:off x="11750040" y="6391656"/>
-            <a:ext cx="1234440" cy="320040"/>
-          </a:xfrm>
-          <a:prstGeom prst="rect">
-            <a:avLst/>
-          </a:prstGeom>
-          <a:noFill/>
-        </p:spPr>
-        <p:txBody>
-          <a:bodyPr wrap="square" anchor="t">
-            <a:spAutoFit/>
-          </a:bodyPr>
-          <a:lstStyle/>
-          <a:p>
-            <a:pPr algn="ctr">
-              <a:defRPr sz="1100" b="0">
-                <a:solidFill>
-                  <a:srgbClr val="FFFFFF"/>
-                </a:solidFill>
-                <a:latin typeface="Microsoft YaHei"/>
-              </a:defRPr>
-            </a:pPr>
-            <a:r>
-              <a:t>产品契合</a:t>
-            </a:r>
-          </a:p>
-        </p:txBody>
-      </p:sp>
-    </p:spTree>
-  </p:cSld>
-  <p:clrMapOvr>
-    <a:masterClrMapping/>
-  </p:clrMapOvr>
-</p:sld>
-</file>
-
-<file path=ppt/slides/slide2.xml><?xml version="1.0" encoding="utf-8"?>
-<p:sld xmlns:a="http://schemas.openxmlformats.org/drawingml/2006/main" xmlns:p="http://schemas.openxmlformats.org/presentationml/2006/main" xmlns:r="http://schemas.openxmlformats.org/officeDocument/2006/relationships">
-  <p:cSld>
-    <p:spTree>
-      <p:nvGrpSpPr>
-        <p:cNvPr id="1" name=""/>
-        <p:cNvGrpSpPr/>
-        <p:nvPr/>
-      </p:nvGrpSpPr>
-      <p:grpSpPr/>
-      <p:sp>
-        <p:nvSpPr>
-          <p:cNvPr id="2" name="Rectangle 1"/>
-          <p:cNvSpPr/>
-          <p:nvPr/>
-        </p:nvSpPr>
-        <p:spPr>
-          <a:xfrm>
-            <a:off x="0" y="0"/>
-            <a:ext cx="12191695" cy="6858000"/>
-          </a:xfrm>
-          <a:prstGeom prst="rect">
-            <a:avLst/>
-          </a:prstGeom>
-          <a:solidFill>
-            <a:srgbClr val="0A1628"/>
-          </a:solidFill>
-          <a:ln>
-            <a:noFill/>
-          </a:ln>
-        </p:spPr>
-        <p:style>
-          <a:lnRef idx="1">
-            <a:schemeClr val="accent1"/>
-          </a:lnRef>
-          <a:fillRef idx="3">
-            <a:schemeClr val="accent1"/>
-          </a:fillRef>
-          <a:effectRef idx="2">
-            <a:schemeClr val="accent1"/>
-          </a:effectRef>
-          <a:fontRef idx="minor">
-            <a:schemeClr val="lt1"/>
-          </a:fontRef>
-        </p:style>
-        <p:txBody>
-          <a:bodyPr rtlCol="0" anchor="ctr"/>
-          <a:lstStyle/>
-          <a:p>
-            <a:pPr algn="ctr"/>
-          </a:p>
-        </p:txBody>
-      </p:sp>
-      <p:sp>
-        <p:nvSpPr>
-          <p:cNvPr id="3" name="TextBox 2"/>
-          <p:cNvSpPr txBox="1"/>
-          <p:nvPr/>
-        </p:nvSpPr>
-        <p:spPr>
-          <a:xfrm>
-            <a:off x="365760" y="137160"/>
-            <a:ext cx="7315200" cy="320040"/>
-          </a:xfrm>
-          <a:prstGeom prst="rect">
-            <a:avLst/>
-          </a:prstGeom>
-          <a:noFill/>
-        </p:spPr>
-        <p:txBody>
-          <a:bodyPr wrap="square" anchor="t">
-            <a:spAutoFit/>
-          </a:bodyPr>
-          <a:lstStyle/>
-          <a:p>
-            <a:pPr algn="l">
-              <a:defRPr sz="1300" b="0">
                 <a:solidFill>
                   <a:srgbClr val="B4BED2"/>
                 </a:solidFill>
@@ -4869,35 +4467,74 @@
               </a:defRPr>
             </a:pPr>
             <a:r>
-              <a:t>参考：完整信息图（第 1 页为可编辑版）</a:t>
+              <a:t>单位经济</a:t>
             </a:r>
           </a:p>
         </p:txBody>
       </p:sp>
       <p:pic>
         <p:nvPicPr>
-          <p:cNvPr id="4" name="Picture 3" descr="ai-industry-chain-infographic-zh-16x9.png"/>
+          <p:cNvPr id="39" name="Picture 38" descr="04-pmf.png"/>
           <p:cNvPicPr>
             <a:picLocks noChangeAspect="1"/>
           </p:cNvPicPr>
           <p:nvPr/>
         </p:nvPicPr>
         <p:blipFill>
-          <a:blip r:embed="rId2"/>
+          <a:blip r:embed="rId15"/>
           <a:stretch>
             <a:fillRect/>
           </a:stretch>
         </p:blipFill>
         <p:spPr>
           <a:xfrm>
-            <a:off x="137160" y="457200"/>
-            <a:ext cx="11887200" cy="6686550"/>
+            <a:off x="11292840" y="5916168"/>
+            <a:ext cx="365760" cy="365760"/>
           </a:xfrm>
           <a:prstGeom prst="rect">
             <a:avLst/>
           </a:prstGeom>
         </p:spPr>
       </p:pic>
+      <p:sp>
+        <p:nvSpPr>
+          <p:cNvPr id="40" name="TextBox 39"/>
+          <p:cNvSpPr txBox="1"/>
+          <p:nvPr/>
+        </p:nvSpPr>
+        <p:spPr>
+          <a:xfrm>
+            <a:off x="10927080" y="6327648"/>
+            <a:ext cx="1188720" cy="320040"/>
+          </a:xfrm>
+          <a:prstGeom prst="rect">
+            <a:avLst/>
+          </a:prstGeom>
+          <a:noFill/>
+        </p:spPr>
+        <p:txBody>
+          <a:bodyPr wrap="square" anchor="t">
+            <a:spAutoFit/>
+          </a:bodyPr>
+          <a:lstStyle/>
+          <a:p>
+            <a:pPr algn="ctr">
+              <a:spcAft>
+                <a:spcPts val="200"/>
+              </a:spcAft>
+              <a:defRPr sz="1100" b="0">
+                <a:solidFill>
+                  <a:srgbClr val="B4BED2"/>
+                </a:solidFill>
+                <a:latin typeface="Microsoft YaHei"/>
+              </a:defRPr>
+            </a:pPr>
+            <a:r>
+              <a:t>产品契合</a:t>
+            </a:r>
+          </a:p>
+        </p:txBody>
+      </p:sp>
     </p:spTree>
   </p:cSld>
   <p:clrMapOvr>

</xml_diff>

<commit_message>
Compose icons as blue PPT circles + white-line PNGs
Column icons: filled blue oval shape under white glyph, grouped.
Footer metrics: white glyph with hollow blue ring outline, grouped.

Co-authored-by: Junwei Wang <junweiwangwjw@icloud.com>
</commit_message>
<xml_diff>
--- a/AI-industry-chain-editable-16x9.pptx
+++ b/AI-industry-chain-editable-16x9.pptx
@@ -3393,33 +3393,91 @@
           </a:p>
         </p:txBody>
       </p:sp>
+      <p:grpSp>
+        <p:nvGrpSpPr>
+          <p:cNvPr id="11" name="IconGroup"/>
+          <p:cNvGrpSpPr/>
+          <p:nvPr/>
+        </p:nvGrpSpPr>
+        <p:grpSpPr>
+          <a:xfrm>
+            <a:off x="1023487" y="2679192"/>
+            <a:ext cx="713232" cy="713232"/>
+            <a:chOff x="1023487" y="2679192"/>
+            <a:chExt cx="713232" cy="713232"/>
+          </a:xfrm>
+        </p:grpSpPr>
+        <p:sp>
+          <p:nvSpPr>
+            <p:cNvPr id="9" name="Oval 8"/>
+            <p:cNvSpPr/>
+            <p:nvPr/>
+          </p:nvSpPr>
+          <p:spPr>
+            <a:xfrm>
+              <a:off x="1023487" y="2679192"/>
+              <a:ext cx="713232" cy="713232"/>
+            </a:xfrm>
+            <a:prstGeom prst="ellipse">
+              <a:avLst/>
+            </a:prstGeom>
+            <a:solidFill>
+              <a:srgbClr val="3B82F6"/>
+            </a:solidFill>
+            <a:ln>
+              <a:noFill/>
+            </a:ln>
+          </p:spPr>
+          <p:style>
+            <a:lnRef idx="1">
+              <a:schemeClr val="accent1"/>
+            </a:lnRef>
+            <a:fillRef idx="3">
+              <a:schemeClr val="accent1"/>
+            </a:fillRef>
+            <a:effectRef idx="2">
+              <a:schemeClr val="accent1"/>
+            </a:effectRef>
+            <a:fontRef idx="minor">
+              <a:schemeClr val="lt1"/>
+            </a:fontRef>
+          </p:style>
+          <p:txBody>
+            <a:bodyPr rtlCol="0" anchor="ctr"/>
+            <a:lstStyle/>
+            <a:p>
+              <a:pPr algn="ctr"/>
+            </a:p>
+          </p:txBody>
+        </p:sp>
+        <p:pic>
+          <p:nvPicPr>
+            <p:cNvPr id="10" name="Picture 9" descr="01-compute.png"/>
+            <p:cNvPicPr>
+              <a:picLocks noChangeAspect="1"/>
+            </p:cNvPicPr>
+            <p:nvPr/>
+          </p:nvPicPr>
+          <p:blipFill>
+            <a:blip r:embed="rId2"/>
+            <a:stretch>
+              <a:fillRect/>
+            </a:stretch>
+          </p:blipFill>
+          <p:spPr>
+            <a:xfrm>
+              <a:off x="1142359" y="2798064"/>
+              <a:ext cx="475488" cy="475488"/>
+            </a:xfrm>
+            <a:prstGeom prst="rect">
+              <a:avLst/>
+            </a:prstGeom>
+          </p:spPr>
+        </p:pic>
+      </p:grpSp>
       <p:pic>
         <p:nvPicPr>
-          <p:cNvPr id="9" name="Picture 8" descr="01-compute.png"/>
-          <p:cNvPicPr>
-            <a:picLocks noChangeAspect="1"/>
-          </p:cNvPicPr>
-          <p:nvPr/>
-        </p:nvPicPr>
-        <p:blipFill>
-          <a:blip r:embed="rId2"/>
-          <a:stretch>
-            <a:fillRect/>
-          </a:stretch>
-        </p:blipFill>
-        <p:spPr>
-          <a:xfrm>
-            <a:off x="1050919" y="2697480"/>
-            <a:ext cx="658368" cy="658368"/>
-          </a:xfrm>
-          <a:prstGeom prst="rect">
-            <a:avLst/>
-          </a:prstGeom>
-        </p:spPr>
-      </p:pic>
-      <p:pic>
-        <p:nvPicPr>
-          <p:cNvPr id="10" name="Picture 9" descr="01-compute.png"/>
+          <p:cNvPr id="12" name="Picture 11" descr="01-compute.png"/>
           <p:cNvPicPr>
             <a:picLocks noChangeAspect="1"/>
           </p:cNvPicPr>
@@ -3443,7 +3501,7 @@
       </p:pic>
       <p:sp>
         <p:nvSpPr>
-          <p:cNvPr id="11" name="Rounded Rectangle 10"/>
+          <p:cNvPr id="13" name="Rounded Rectangle 12"/>
           <p:cNvSpPr/>
           <p:nvPr/>
         </p:nvSpPr>
@@ -3490,7 +3548,7 @@
       </p:sp>
       <p:sp>
         <p:nvSpPr>
-          <p:cNvPr id="12" name="TextBox 11"/>
+          <p:cNvPr id="14" name="TextBox 13"/>
           <p:cNvSpPr txBox="1"/>
           <p:nvPr/>
         </p:nvSpPr>
@@ -3529,7 +3587,7 @@
       </p:sp>
       <p:sp>
         <p:nvSpPr>
-          <p:cNvPr id="13" name="TextBox 12"/>
+          <p:cNvPr id="15" name="TextBox 14"/>
           <p:cNvSpPr txBox="1"/>
           <p:nvPr/>
         </p:nvSpPr>
@@ -3582,33 +3640,91 @@
           </a:p>
         </p:txBody>
       </p:sp>
+      <p:grpSp>
+        <p:nvGrpSpPr>
+          <p:cNvPr id="18" name="IconGroup"/>
+          <p:cNvGrpSpPr/>
+          <p:nvPr/>
+        </p:nvGrpSpPr>
+        <p:grpSpPr>
+          <a:xfrm>
+            <a:off x="3381359" y="2679192"/>
+            <a:ext cx="713232" cy="713232"/>
+            <a:chOff x="3381359" y="2679192"/>
+            <a:chExt cx="713232" cy="713232"/>
+          </a:xfrm>
+        </p:grpSpPr>
+        <p:sp>
+          <p:nvSpPr>
+            <p:cNvPr id="16" name="Oval 15"/>
+            <p:cNvSpPr/>
+            <p:nvPr/>
+          </p:nvSpPr>
+          <p:spPr>
+            <a:xfrm>
+              <a:off x="3381359" y="2679192"/>
+              <a:ext cx="713232" cy="713232"/>
+            </a:xfrm>
+            <a:prstGeom prst="ellipse">
+              <a:avLst/>
+            </a:prstGeom>
+            <a:solidFill>
+              <a:srgbClr val="3B82F6"/>
+            </a:solidFill>
+            <a:ln>
+              <a:noFill/>
+            </a:ln>
+          </p:spPr>
+          <p:style>
+            <a:lnRef idx="1">
+              <a:schemeClr val="accent1"/>
+            </a:lnRef>
+            <a:fillRef idx="3">
+              <a:schemeClr val="accent1"/>
+            </a:fillRef>
+            <a:effectRef idx="2">
+              <a:schemeClr val="accent1"/>
+            </a:effectRef>
+            <a:fontRef idx="minor">
+              <a:schemeClr val="lt1"/>
+            </a:fontRef>
+          </p:style>
+          <p:txBody>
+            <a:bodyPr rtlCol="0" anchor="ctr"/>
+            <a:lstStyle/>
+            <a:p>
+              <a:pPr algn="ctr"/>
+            </a:p>
+          </p:txBody>
+        </p:sp>
+        <p:pic>
+          <p:nvPicPr>
+            <p:cNvPr id="17" name="Picture 16" descr="02-infra.png"/>
+            <p:cNvPicPr>
+              <a:picLocks noChangeAspect="1"/>
+            </p:cNvPicPr>
+            <p:nvPr/>
+          </p:nvPicPr>
+          <p:blipFill>
+            <a:blip r:embed="rId4"/>
+            <a:stretch>
+              <a:fillRect/>
+            </a:stretch>
+          </p:blipFill>
+          <p:spPr>
+            <a:xfrm>
+              <a:off x="3500231" y="2798064"/>
+              <a:ext cx="475488" cy="475488"/>
+            </a:xfrm>
+            <a:prstGeom prst="rect">
+              <a:avLst/>
+            </a:prstGeom>
+          </p:spPr>
+        </p:pic>
+      </p:grpSp>
       <p:pic>
         <p:nvPicPr>
-          <p:cNvPr id="14" name="Picture 13" descr="02-infra.png"/>
-          <p:cNvPicPr>
-            <a:picLocks noChangeAspect="1"/>
-          </p:cNvPicPr>
-          <p:nvPr/>
-        </p:nvPicPr>
-        <p:blipFill>
-          <a:blip r:embed="rId4"/>
-          <a:stretch>
-            <a:fillRect/>
-          </a:stretch>
-        </p:blipFill>
-        <p:spPr>
-          <a:xfrm>
-            <a:off x="3408791" y="2697480"/>
-            <a:ext cx="658368" cy="658368"/>
-          </a:xfrm>
-          <a:prstGeom prst="rect">
-            <a:avLst/>
-          </a:prstGeom>
-        </p:spPr>
-      </p:pic>
-      <p:pic>
-        <p:nvPicPr>
-          <p:cNvPr id="15" name="Picture 14" descr="02-infra.png"/>
+          <p:cNvPr id="19" name="Picture 18" descr="02-infra.png"/>
           <p:cNvPicPr>
             <a:picLocks noChangeAspect="1"/>
           </p:cNvPicPr>
@@ -3632,7 +3748,7 @@
       </p:pic>
       <p:sp>
         <p:nvSpPr>
-          <p:cNvPr id="16" name="Rounded Rectangle 15"/>
+          <p:cNvPr id="20" name="Rounded Rectangle 19"/>
           <p:cNvSpPr/>
           <p:nvPr/>
         </p:nvSpPr>
@@ -3679,7 +3795,7 @@
       </p:sp>
       <p:sp>
         <p:nvSpPr>
-          <p:cNvPr id="17" name="TextBox 16"/>
+          <p:cNvPr id="21" name="TextBox 20"/>
           <p:cNvSpPr txBox="1"/>
           <p:nvPr/>
         </p:nvSpPr>
@@ -3718,7 +3834,7 @@
       </p:sp>
       <p:sp>
         <p:nvSpPr>
-          <p:cNvPr id="18" name="TextBox 17"/>
+          <p:cNvPr id="22" name="TextBox 21"/>
           <p:cNvSpPr txBox="1"/>
           <p:nvPr/>
         </p:nvSpPr>
@@ -3771,33 +3887,91 @@
           </a:p>
         </p:txBody>
       </p:sp>
+      <p:grpSp>
+        <p:nvGrpSpPr>
+          <p:cNvPr id="25" name="IconGroup"/>
+          <p:cNvGrpSpPr/>
+          <p:nvPr/>
+        </p:nvGrpSpPr>
+        <p:grpSpPr>
+          <a:xfrm>
+            <a:off x="5739231" y="2679192"/>
+            <a:ext cx="713232" cy="713232"/>
+            <a:chOff x="5739231" y="2679192"/>
+            <a:chExt cx="713232" cy="713232"/>
+          </a:xfrm>
+        </p:grpSpPr>
+        <p:sp>
+          <p:nvSpPr>
+            <p:cNvPr id="23" name="Oval 22"/>
+            <p:cNvSpPr/>
+            <p:nvPr/>
+          </p:nvSpPr>
+          <p:spPr>
+            <a:xfrm>
+              <a:off x="5739231" y="2679192"/>
+              <a:ext cx="713232" cy="713232"/>
+            </a:xfrm>
+            <a:prstGeom prst="ellipse">
+              <a:avLst/>
+            </a:prstGeom>
+            <a:solidFill>
+              <a:srgbClr val="3B82F6"/>
+            </a:solidFill>
+            <a:ln>
+              <a:noFill/>
+            </a:ln>
+          </p:spPr>
+          <p:style>
+            <a:lnRef idx="1">
+              <a:schemeClr val="accent1"/>
+            </a:lnRef>
+            <a:fillRef idx="3">
+              <a:schemeClr val="accent1"/>
+            </a:fillRef>
+            <a:effectRef idx="2">
+              <a:schemeClr val="accent1"/>
+            </a:effectRef>
+            <a:fontRef idx="minor">
+              <a:schemeClr val="lt1"/>
+            </a:fontRef>
+          </p:style>
+          <p:txBody>
+            <a:bodyPr rtlCol="0" anchor="ctr"/>
+            <a:lstStyle/>
+            <a:p>
+              <a:pPr algn="ctr"/>
+            </a:p>
+          </p:txBody>
+        </p:sp>
+        <p:pic>
+          <p:nvPicPr>
+            <p:cNvPr id="24" name="Picture 23" descr="03-model.png"/>
+            <p:cNvPicPr>
+              <a:picLocks noChangeAspect="1"/>
+            </p:cNvPicPr>
+            <p:nvPr/>
+          </p:nvPicPr>
+          <p:blipFill>
+            <a:blip r:embed="rId6"/>
+            <a:stretch>
+              <a:fillRect/>
+            </a:stretch>
+          </p:blipFill>
+          <p:spPr>
+            <a:xfrm>
+              <a:off x="5858103" y="2798064"/>
+              <a:ext cx="475488" cy="475488"/>
+            </a:xfrm>
+            <a:prstGeom prst="rect">
+              <a:avLst/>
+            </a:prstGeom>
+          </p:spPr>
+        </p:pic>
+      </p:grpSp>
       <p:pic>
         <p:nvPicPr>
-          <p:cNvPr id="19" name="Picture 18" descr="03-model.png"/>
-          <p:cNvPicPr>
-            <a:picLocks noChangeAspect="1"/>
-          </p:cNvPicPr>
-          <p:nvPr/>
-        </p:nvPicPr>
-        <p:blipFill>
-          <a:blip r:embed="rId6"/>
-          <a:stretch>
-            <a:fillRect/>
-          </a:stretch>
-        </p:blipFill>
-        <p:spPr>
-          <a:xfrm>
-            <a:off x="5766663" y="2697480"/>
-            <a:ext cx="658368" cy="658368"/>
-          </a:xfrm>
-          <a:prstGeom prst="rect">
-            <a:avLst/>
-          </a:prstGeom>
-        </p:spPr>
-      </p:pic>
-      <p:pic>
-        <p:nvPicPr>
-          <p:cNvPr id="20" name="Picture 19" descr="03-model.png"/>
+          <p:cNvPr id="26" name="Picture 25" descr="03-model.png"/>
           <p:cNvPicPr>
             <a:picLocks noChangeAspect="1"/>
           </p:cNvPicPr>
@@ -3821,7 +3995,7 @@
       </p:pic>
       <p:sp>
         <p:nvSpPr>
-          <p:cNvPr id="21" name="Rounded Rectangle 20"/>
+          <p:cNvPr id="27" name="Rounded Rectangle 26"/>
           <p:cNvSpPr/>
           <p:nvPr/>
         </p:nvSpPr>
@@ -3868,7 +4042,7 @@
       </p:sp>
       <p:sp>
         <p:nvSpPr>
-          <p:cNvPr id="22" name="TextBox 21"/>
+          <p:cNvPr id="28" name="TextBox 27"/>
           <p:cNvSpPr txBox="1"/>
           <p:nvPr/>
         </p:nvSpPr>
@@ -3907,7 +4081,7 @@
       </p:sp>
       <p:sp>
         <p:nvSpPr>
-          <p:cNvPr id="23" name="TextBox 22"/>
+          <p:cNvPr id="29" name="TextBox 28"/>
           <p:cNvSpPr txBox="1"/>
           <p:nvPr/>
         </p:nvSpPr>
@@ -3960,33 +4134,91 @@
           </a:p>
         </p:txBody>
       </p:sp>
+      <p:grpSp>
+        <p:nvGrpSpPr>
+          <p:cNvPr id="32" name="IconGroup"/>
+          <p:cNvGrpSpPr/>
+          <p:nvPr/>
+        </p:nvGrpSpPr>
+        <p:grpSpPr>
+          <a:xfrm>
+            <a:off x="8097103" y="2679192"/>
+            <a:ext cx="713232" cy="713232"/>
+            <a:chOff x="8097103" y="2679192"/>
+            <a:chExt cx="713232" cy="713232"/>
+          </a:xfrm>
+        </p:grpSpPr>
+        <p:sp>
+          <p:nvSpPr>
+            <p:cNvPr id="30" name="Oval 29"/>
+            <p:cNvSpPr/>
+            <p:nvPr/>
+          </p:nvSpPr>
+          <p:spPr>
+            <a:xfrm>
+              <a:off x="8097103" y="2679192"/>
+              <a:ext cx="713232" cy="713232"/>
+            </a:xfrm>
+            <a:prstGeom prst="ellipse">
+              <a:avLst/>
+            </a:prstGeom>
+            <a:solidFill>
+              <a:srgbClr val="3B82F6"/>
+            </a:solidFill>
+            <a:ln>
+              <a:noFill/>
+            </a:ln>
+          </p:spPr>
+          <p:style>
+            <a:lnRef idx="1">
+              <a:schemeClr val="accent1"/>
+            </a:lnRef>
+            <a:fillRef idx="3">
+              <a:schemeClr val="accent1"/>
+            </a:fillRef>
+            <a:effectRef idx="2">
+              <a:schemeClr val="accent1"/>
+            </a:effectRef>
+            <a:fontRef idx="minor">
+              <a:schemeClr val="lt1"/>
+            </a:fontRef>
+          </p:style>
+          <p:txBody>
+            <a:bodyPr rtlCol="0" anchor="ctr"/>
+            <a:lstStyle/>
+            <a:p>
+              <a:pPr algn="ctr"/>
+            </a:p>
+          </p:txBody>
+        </p:sp>
+        <p:pic>
+          <p:nvPicPr>
+            <p:cNvPr id="31" name="Picture 30" descr="04-agent.png"/>
+            <p:cNvPicPr>
+              <a:picLocks noChangeAspect="1"/>
+            </p:cNvPicPr>
+            <p:nvPr/>
+          </p:nvPicPr>
+          <p:blipFill>
+            <a:blip r:embed="rId8"/>
+            <a:stretch>
+              <a:fillRect/>
+            </a:stretch>
+          </p:blipFill>
+          <p:spPr>
+            <a:xfrm>
+              <a:off x="8215975" y="2798064"/>
+              <a:ext cx="475488" cy="475488"/>
+            </a:xfrm>
+            <a:prstGeom prst="rect">
+              <a:avLst/>
+            </a:prstGeom>
+          </p:spPr>
+        </p:pic>
+      </p:grpSp>
       <p:pic>
         <p:nvPicPr>
-          <p:cNvPr id="24" name="Picture 23" descr="04-agent.png"/>
-          <p:cNvPicPr>
-            <a:picLocks noChangeAspect="1"/>
-          </p:cNvPicPr>
-          <p:nvPr/>
-        </p:nvPicPr>
-        <p:blipFill>
-          <a:blip r:embed="rId8"/>
-          <a:stretch>
-            <a:fillRect/>
-          </a:stretch>
-        </p:blipFill>
-        <p:spPr>
-          <a:xfrm>
-            <a:off x="8124535" y="2697480"/>
-            <a:ext cx="658368" cy="658368"/>
-          </a:xfrm>
-          <a:prstGeom prst="rect">
-            <a:avLst/>
-          </a:prstGeom>
-        </p:spPr>
-      </p:pic>
-      <p:pic>
-        <p:nvPicPr>
-          <p:cNvPr id="25" name="Picture 24" descr="04-agent.png"/>
+          <p:cNvPr id="33" name="Picture 32" descr="04-agent.png"/>
           <p:cNvPicPr>
             <a:picLocks noChangeAspect="1"/>
           </p:cNvPicPr>
@@ -4010,7 +4242,7 @@
       </p:pic>
       <p:sp>
         <p:nvSpPr>
-          <p:cNvPr id="26" name="Rounded Rectangle 25"/>
+          <p:cNvPr id="34" name="Rounded Rectangle 33"/>
           <p:cNvSpPr/>
           <p:nvPr/>
         </p:nvSpPr>
@@ -4057,7 +4289,7 @@
       </p:sp>
       <p:sp>
         <p:nvSpPr>
-          <p:cNvPr id="27" name="TextBox 26"/>
+          <p:cNvPr id="35" name="TextBox 34"/>
           <p:cNvSpPr txBox="1"/>
           <p:nvPr/>
         </p:nvSpPr>
@@ -4096,7 +4328,7 @@
       </p:sp>
       <p:sp>
         <p:nvSpPr>
-          <p:cNvPr id="28" name="TextBox 27"/>
+          <p:cNvPr id="36" name="TextBox 35"/>
           <p:cNvSpPr txBox="1"/>
           <p:nvPr/>
         </p:nvSpPr>
@@ -4149,33 +4381,91 @@
           </a:p>
         </p:txBody>
       </p:sp>
+      <p:grpSp>
+        <p:nvGrpSpPr>
+          <p:cNvPr id="39" name="IconGroup"/>
+          <p:cNvGrpSpPr/>
+          <p:nvPr/>
+        </p:nvGrpSpPr>
+        <p:grpSpPr>
+          <a:xfrm>
+            <a:off x="10454975" y="2679192"/>
+            <a:ext cx="713232" cy="713232"/>
+            <a:chOff x="10454975" y="2679192"/>
+            <a:chExt cx="713232" cy="713232"/>
+          </a:xfrm>
+        </p:grpSpPr>
+        <p:sp>
+          <p:nvSpPr>
+            <p:cNvPr id="37" name="Oval 36"/>
+            <p:cNvSpPr/>
+            <p:nvPr/>
+          </p:nvSpPr>
+          <p:spPr>
+            <a:xfrm>
+              <a:off x="10454975" y="2679192"/>
+              <a:ext cx="713232" cy="713232"/>
+            </a:xfrm>
+            <a:prstGeom prst="ellipse">
+              <a:avLst/>
+            </a:prstGeom>
+            <a:solidFill>
+              <a:srgbClr val="3B82F6"/>
+            </a:solidFill>
+            <a:ln>
+              <a:noFill/>
+            </a:ln>
+          </p:spPr>
+          <p:style>
+            <a:lnRef idx="1">
+              <a:schemeClr val="accent1"/>
+            </a:lnRef>
+            <a:fillRef idx="3">
+              <a:schemeClr val="accent1"/>
+            </a:fillRef>
+            <a:effectRef idx="2">
+              <a:schemeClr val="accent1"/>
+            </a:effectRef>
+            <a:fontRef idx="minor">
+              <a:schemeClr val="lt1"/>
+            </a:fontRef>
+          </p:style>
+          <p:txBody>
+            <a:bodyPr rtlCol="0" anchor="ctr"/>
+            <a:lstStyle/>
+            <a:p>
+              <a:pPr algn="ctr"/>
+            </a:p>
+          </p:txBody>
+        </p:sp>
+        <p:pic>
+          <p:nvPicPr>
+            <p:cNvPr id="38" name="Picture 37" descr="05-app.png"/>
+            <p:cNvPicPr>
+              <a:picLocks noChangeAspect="1"/>
+            </p:cNvPicPr>
+            <p:nvPr/>
+          </p:nvPicPr>
+          <p:blipFill>
+            <a:blip r:embed="rId10"/>
+            <a:stretch>
+              <a:fillRect/>
+            </a:stretch>
+          </p:blipFill>
+          <p:spPr>
+            <a:xfrm>
+              <a:off x="10573847" y="2798064"/>
+              <a:ext cx="475488" cy="475488"/>
+            </a:xfrm>
+            <a:prstGeom prst="rect">
+              <a:avLst/>
+            </a:prstGeom>
+          </p:spPr>
+        </p:pic>
+      </p:grpSp>
       <p:pic>
         <p:nvPicPr>
-          <p:cNvPr id="29" name="Picture 28" descr="05-app.png"/>
-          <p:cNvPicPr>
-            <a:picLocks noChangeAspect="1"/>
-          </p:cNvPicPr>
-          <p:nvPr/>
-        </p:nvPicPr>
-        <p:blipFill>
-          <a:blip r:embed="rId10"/>
-          <a:stretch>
-            <a:fillRect/>
-          </a:stretch>
-        </p:blipFill>
-        <p:spPr>
-          <a:xfrm>
-            <a:off x="10482407" y="2697480"/>
-            <a:ext cx="658368" cy="658368"/>
-          </a:xfrm>
-          <a:prstGeom prst="rect">
-            <a:avLst/>
-          </a:prstGeom>
-        </p:spPr>
-      </p:pic>
-      <p:pic>
-        <p:nvPicPr>
-          <p:cNvPr id="30" name="Picture 29" descr="05-app.png"/>
+          <p:cNvPr id="40" name="Picture 39" descr="05-app.png"/>
           <p:cNvPicPr>
             <a:picLocks noChangeAspect="1"/>
           </p:cNvPicPr>
@@ -4199,7 +4489,7 @@
       </p:pic>
       <p:sp>
         <p:nvSpPr>
-          <p:cNvPr id="31" name="Rectangle 30"/>
+          <p:cNvPr id="41" name="Rectangle 40"/>
           <p:cNvSpPr/>
           <p:nvPr/>
         </p:nvSpPr>
@@ -4242,7 +4532,7 @@
       </p:sp>
       <p:sp>
         <p:nvSpPr>
-          <p:cNvPr id="32" name="TextBox 31"/>
+          <p:cNvPr id="42" name="TextBox 41"/>
           <p:cNvSpPr txBox="1"/>
           <p:nvPr/>
         </p:nvSpPr>
@@ -4283,39 +4573,97 @@
           </a:p>
         </p:txBody>
       </p:sp>
-      <p:pic>
-        <p:nvPicPr>
-          <p:cNvPr id="33" name="Picture 32" descr="01-capex.png"/>
-          <p:cNvPicPr>
-            <a:picLocks noChangeAspect="1"/>
-          </p:cNvPicPr>
+      <p:grpSp>
+        <p:nvGrpSpPr>
+          <p:cNvPr id="45" name="IconGroup"/>
+          <p:cNvGrpSpPr/>
           <p:nvPr/>
-        </p:nvPicPr>
-        <p:blipFill>
-          <a:blip r:embed="rId12"/>
-          <a:stretch>
-            <a:fillRect/>
-          </a:stretch>
-        </p:blipFill>
-        <p:spPr>
-          <a:xfrm>
-            <a:off x="7315200" y="5916168"/>
-            <a:ext cx="365760" cy="365760"/>
-          </a:xfrm>
-          <a:prstGeom prst="rect">
-            <a:avLst/>
-          </a:prstGeom>
-        </p:spPr>
-      </p:pic>
-      <p:sp>
-        <p:nvSpPr>
-          <p:cNvPr id="34" name="TextBox 33"/>
+        </p:nvGrpSpPr>
+        <p:grpSpPr>
+          <a:xfrm>
+            <a:off x="7333488" y="5897880"/>
+            <a:ext cx="420624" cy="420624"/>
+            <a:chOff x="7333488" y="5897880"/>
+            <a:chExt cx="420624" cy="420624"/>
+          </a:xfrm>
+        </p:grpSpPr>
+        <p:sp>
+          <p:nvSpPr>
+            <p:cNvPr id="43" name="Oval 42"/>
+            <p:cNvSpPr/>
+            <p:nvPr/>
+          </p:nvSpPr>
+          <p:spPr>
+            <a:xfrm>
+              <a:off x="7333488" y="5897880"/>
+              <a:ext cx="420624" cy="420624"/>
+            </a:xfrm>
+            <a:prstGeom prst="ellipse">
+              <a:avLst/>
+            </a:prstGeom>
+            <a:noFill/>
+            <a:ln w="22225">
+              <a:solidFill>
+                <a:srgbClr val="3B82F6"/>
+              </a:solidFill>
+            </a:ln>
+          </p:spPr>
+          <p:style>
+            <a:lnRef idx="1">
+              <a:schemeClr val="accent1"/>
+            </a:lnRef>
+            <a:fillRef idx="3">
+              <a:schemeClr val="accent1"/>
+            </a:fillRef>
+            <a:effectRef idx="2">
+              <a:schemeClr val="accent1"/>
+            </a:effectRef>
+            <a:fontRef idx="minor">
+              <a:schemeClr val="lt1"/>
+            </a:fontRef>
+          </p:style>
+          <p:txBody>
+            <a:bodyPr rtlCol="0" anchor="ctr"/>
+            <a:lstStyle/>
+            <a:p>
+              <a:pPr algn="ctr"/>
+            </a:p>
+          </p:txBody>
+        </p:sp>
+        <p:pic>
+          <p:nvPicPr>
+            <p:cNvPr id="44" name="Picture 43" descr="01-capex.png"/>
+            <p:cNvPicPr>
+              <a:picLocks noChangeAspect="1"/>
+            </p:cNvPicPr>
+            <p:nvPr/>
+          </p:nvPicPr>
+          <p:blipFill>
+            <a:blip r:embed="rId12"/>
+            <a:stretch>
+              <a:fillRect/>
+            </a:stretch>
+          </p:blipFill>
+          <p:spPr>
+            <a:xfrm>
+              <a:off x="7397496" y="5961888"/>
+              <a:ext cx="292608" cy="292608"/>
+            </a:xfrm>
+            <a:prstGeom prst="rect">
+              <a:avLst/>
+            </a:prstGeom>
+          </p:spPr>
+        </p:pic>
+      </p:grpSp>
+      <p:sp>
+        <p:nvSpPr>
+          <p:cNvPr id="46" name="TextBox 45"/>
           <p:cNvSpPr txBox="1"/>
           <p:nvPr/>
         </p:nvSpPr>
         <p:spPr>
           <a:xfrm>
-            <a:off x="6949440" y="6327648"/>
+            <a:off x="6949440" y="6336792"/>
             <a:ext cx="1188720" cy="320040"/>
           </a:xfrm>
           <a:prstGeom prst="rect">
@@ -4346,39 +4694,97 @@
           </a:p>
         </p:txBody>
       </p:sp>
-      <p:pic>
-        <p:nvPicPr>
-          <p:cNvPr id="35" name="Picture 34" descr="02-latency.png"/>
-          <p:cNvPicPr>
-            <a:picLocks noChangeAspect="1"/>
-          </p:cNvPicPr>
+      <p:grpSp>
+        <p:nvGrpSpPr>
+          <p:cNvPr id="49" name="IconGroup"/>
+          <p:cNvGrpSpPr/>
           <p:nvPr/>
-        </p:nvPicPr>
-        <p:blipFill>
-          <a:blip r:embed="rId13"/>
-          <a:stretch>
-            <a:fillRect/>
-          </a:stretch>
-        </p:blipFill>
-        <p:spPr>
-          <a:xfrm>
-            <a:off x="8641080" y="5916168"/>
-            <a:ext cx="365760" cy="365760"/>
-          </a:xfrm>
-          <a:prstGeom prst="rect">
-            <a:avLst/>
-          </a:prstGeom>
-        </p:spPr>
-      </p:pic>
-      <p:sp>
-        <p:nvSpPr>
-          <p:cNvPr id="36" name="TextBox 35"/>
+        </p:nvGrpSpPr>
+        <p:grpSpPr>
+          <a:xfrm>
+            <a:off x="8659368" y="5897880"/>
+            <a:ext cx="420624" cy="420624"/>
+            <a:chOff x="8659368" y="5897880"/>
+            <a:chExt cx="420624" cy="420624"/>
+          </a:xfrm>
+        </p:grpSpPr>
+        <p:sp>
+          <p:nvSpPr>
+            <p:cNvPr id="47" name="Oval 46"/>
+            <p:cNvSpPr/>
+            <p:nvPr/>
+          </p:nvSpPr>
+          <p:spPr>
+            <a:xfrm>
+              <a:off x="8659368" y="5897880"/>
+              <a:ext cx="420624" cy="420624"/>
+            </a:xfrm>
+            <a:prstGeom prst="ellipse">
+              <a:avLst/>
+            </a:prstGeom>
+            <a:noFill/>
+            <a:ln w="22225">
+              <a:solidFill>
+                <a:srgbClr val="3B82F6"/>
+              </a:solidFill>
+            </a:ln>
+          </p:spPr>
+          <p:style>
+            <a:lnRef idx="1">
+              <a:schemeClr val="accent1"/>
+            </a:lnRef>
+            <a:fillRef idx="3">
+              <a:schemeClr val="accent1"/>
+            </a:fillRef>
+            <a:effectRef idx="2">
+              <a:schemeClr val="accent1"/>
+            </a:effectRef>
+            <a:fontRef idx="minor">
+              <a:schemeClr val="lt1"/>
+            </a:fontRef>
+          </p:style>
+          <p:txBody>
+            <a:bodyPr rtlCol="0" anchor="ctr"/>
+            <a:lstStyle/>
+            <a:p>
+              <a:pPr algn="ctr"/>
+            </a:p>
+          </p:txBody>
+        </p:sp>
+        <p:pic>
+          <p:nvPicPr>
+            <p:cNvPr id="48" name="Picture 47" descr="02-latency.png"/>
+            <p:cNvPicPr>
+              <a:picLocks noChangeAspect="1"/>
+            </p:cNvPicPr>
+            <p:nvPr/>
+          </p:nvPicPr>
+          <p:blipFill>
+            <a:blip r:embed="rId13"/>
+            <a:stretch>
+              <a:fillRect/>
+            </a:stretch>
+          </p:blipFill>
+          <p:spPr>
+            <a:xfrm>
+              <a:off x="8723376" y="5961888"/>
+              <a:ext cx="292608" cy="292608"/>
+            </a:xfrm>
+            <a:prstGeom prst="rect">
+              <a:avLst/>
+            </a:prstGeom>
+          </p:spPr>
+        </p:pic>
+      </p:grpSp>
+      <p:sp>
+        <p:nvSpPr>
+          <p:cNvPr id="50" name="TextBox 49"/>
           <p:cNvSpPr txBox="1"/>
           <p:nvPr/>
         </p:nvSpPr>
         <p:spPr>
           <a:xfrm>
-            <a:off x="8275320" y="6327648"/>
+            <a:off x="8275320" y="6336792"/>
             <a:ext cx="1188720" cy="320040"/>
           </a:xfrm>
           <a:prstGeom prst="rect">
@@ -4409,39 +4815,97 @@
           </a:p>
         </p:txBody>
       </p:sp>
-      <p:pic>
-        <p:nvPicPr>
-          <p:cNvPr id="37" name="Picture 36" descr="03-unit.png"/>
-          <p:cNvPicPr>
-            <a:picLocks noChangeAspect="1"/>
-          </p:cNvPicPr>
+      <p:grpSp>
+        <p:nvGrpSpPr>
+          <p:cNvPr id="53" name="IconGroup"/>
+          <p:cNvGrpSpPr/>
           <p:nvPr/>
-        </p:nvPicPr>
-        <p:blipFill>
-          <a:blip r:embed="rId14"/>
-          <a:stretch>
-            <a:fillRect/>
-          </a:stretch>
-        </p:blipFill>
-        <p:spPr>
-          <a:xfrm>
-            <a:off x="9966960" y="5916168"/>
-            <a:ext cx="365760" cy="365760"/>
-          </a:xfrm>
-          <a:prstGeom prst="rect">
-            <a:avLst/>
-          </a:prstGeom>
-        </p:spPr>
-      </p:pic>
-      <p:sp>
-        <p:nvSpPr>
-          <p:cNvPr id="38" name="TextBox 37"/>
+        </p:nvGrpSpPr>
+        <p:grpSpPr>
+          <a:xfrm>
+            <a:off x="9985248" y="5897880"/>
+            <a:ext cx="420624" cy="420624"/>
+            <a:chOff x="9985248" y="5897880"/>
+            <a:chExt cx="420624" cy="420624"/>
+          </a:xfrm>
+        </p:grpSpPr>
+        <p:sp>
+          <p:nvSpPr>
+            <p:cNvPr id="51" name="Oval 50"/>
+            <p:cNvSpPr/>
+            <p:nvPr/>
+          </p:nvSpPr>
+          <p:spPr>
+            <a:xfrm>
+              <a:off x="9985248" y="5897880"/>
+              <a:ext cx="420624" cy="420624"/>
+            </a:xfrm>
+            <a:prstGeom prst="ellipse">
+              <a:avLst/>
+            </a:prstGeom>
+            <a:noFill/>
+            <a:ln w="22225">
+              <a:solidFill>
+                <a:srgbClr val="3B82F6"/>
+              </a:solidFill>
+            </a:ln>
+          </p:spPr>
+          <p:style>
+            <a:lnRef idx="1">
+              <a:schemeClr val="accent1"/>
+            </a:lnRef>
+            <a:fillRef idx="3">
+              <a:schemeClr val="accent1"/>
+            </a:fillRef>
+            <a:effectRef idx="2">
+              <a:schemeClr val="accent1"/>
+            </a:effectRef>
+            <a:fontRef idx="minor">
+              <a:schemeClr val="lt1"/>
+            </a:fontRef>
+          </p:style>
+          <p:txBody>
+            <a:bodyPr rtlCol="0" anchor="ctr"/>
+            <a:lstStyle/>
+            <a:p>
+              <a:pPr algn="ctr"/>
+            </a:p>
+          </p:txBody>
+        </p:sp>
+        <p:pic>
+          <p:nvPicPr>
+            <p:cNvPr id="52" name="Picture 51" descr="03-unit.png"/>
+            <p:cNvPicPr>
+              <a:picLocks noChangeAspect="1"/>
+            </p:cNvPicPr>
+            <p:nvPr/>
+          </p:nvPicPr>
+          <p:blipFill>
+            <a:blip r:embed="rId14"/>
+            <a:stretch>
+              <a:fillRect/>
+            </a:stretch>
+          </p:blipFill>
+          <p:spPr>
+            <a:xfrm>
+              <a:off x="10049256" y="5961888"/>
+              <a:ext cx="292608" cy="292608"/>
+            </a:xfrm>
+            <a:prstGeom prst="rect">
+              <a:avLst/>
+            </a:prstGeom>
+          </p:spPr>
+        </p:pic>
+      </p:grpSp>
+      <p:sp>
+        <p:nvSpPr>
+          <p:cNvPr id="54" name="TextBox 53"/>
           <p:cNvSpPr txBox="1"/>
           <p:nvPr/>
         </p:nvSpPr>
         <p:spPr>
           <a:xfrm>
-            <a:off x="9601200" y="6327648"/>
+            <a:off x="9601200" y="6336792"/>
             <a:ext cx="1188720" cy="320040"/>
           </a:xfrm>
           <a:prstGeom prst="rect">
@@ -4472,39 +4936,97 @@
           </a:p>
         </p:txBody>
       </p:sp>
-      <p:pic>
-        <p:nvPicPr>
-          <p:cNvPr id="39" name="Picture 38" descr="04-pmf.png"/>
-          <p:cNvPicPr>
-            <a:picLocks noChangeAspect="1"/>
-          </p:cNvPicPr>
+      <p:grpSp>
+        <p:nvGrpSpPr>
+          <p:cNvPr id="57" name="IconGroup"/>
+          <p:cNvGrpSpPr/>
           <p:nvPr/>
-        </p:nvPicPr>
-        <p:blipFill>
-          <a:blip r:embed="rId15"/>
-          <a:stretch>
-            <a:fillRect/>
-          </a:stretch>
-        </p:blipFill>
-        <p:spPr>
-          <a:xfrm>
-            <a:off x="11292840" y="5916168"/>
-            <a:ext cx="365760" cy="365760"/>
-          </a:xfrm>
-          <a:prstGeom prst="rect">
-            <a:avLst/>
-          </a:prstGeom>
-        </p:spPr>
-      </p:pic>
-      <p:sp>
-        <p:nvSpPr>
-          <p:cNvPr id="40" name="TextBox 39"/>
+        </p:nvGrpSpPr>
+        <p:grpSpPr>
+          <a:xfrm>
+            <a:off x="11311128" y="5897880"/>
+            <a:ext cx="420624" cy="420624"/>
+            <a:chOff x="11311128" y="5897880"/>
+            <a:chExt cx="420624" cy="420624"/>
+          </a:xfrm>
+        </p:grpSpPr>
+        <p:sp>
+          <p:nvSpPr>
+            <p:cNvPr id="55" name="Oval 54"/>
+            <p:cNvSpPr/>
+            <p:nvPr/>
+          </p:nvSpPr>
+          <p:spPr>
+            <a:xfrm>
+              <a:off x="11311128" y="5897880"/>
+              <a:ext cx="420624" cy="420624"/>
+            </a:xfrm>
+            <a:prstGeom prst="ellipse">
+              <a:avLst/>
+            </a:prstGeom>
+            <a:noFill/>
+            <a:ln w="22225">
+              <a:solidFill>
+                <a:srgbClr val="3B82F6"/>
+              </a:solidFill>
+            </a:ln>
+          </p:spPr>
+          <p:style>
+            <a:lnRef idx="1">
+              <a:schemeClr val="accent1"/>
+            </a:lnRef>
+            <a:fillRef idx="3">
+              <a:schemeClr val="accent1"/>
+            </a:fillRef>
+            <a:effectRef idx="2">
+              <a:schemeClr val="accent1"/>
+            </a:effectRef>
+            <a:fontRef idx="minor">
+              <a:schemeClr val="lt1"/>
+            </a:fontRef>
+          </p:style>
+          <p:txBody>
+            <a:bodyPr rtlCol="0" anchor="ctr"/>
+            <a:lstStyle/>
+            <a:p>
+              <a:pPr algn="ctr"/>
+            </a:p>
+          </p:txBody>
+        </p:sp>
+        <p:pic>
+          <p:nvPicPr>
+            <p:cNvPr id="56" name="Picture 55" descr="04-pmf.png"/>
+            <p:cNvPicPr>
+              <a:picLocks noChangeAspect="1"/>
+            </p:cNvPicPr>
+            <p:nvPr/>
+          </p:nvPicPr>
+          <p:blipFill>
+            <a:blip r:embed="rId15"/>
+            <a:stretch>
+              <a:fillRect/>
+            </a:stretch>
+          </p:blipFill>
+          <p:spPr>
+            <a:xfrm>
+              <a:off x="11375136" y="5961888"/>
+              <a:ext cx="292608" cy="292608"/>
+            </a:xfrm>
+            <a:prstGeom prst="rect">
+              <a:avLst/>
+            </a:prstGeom>
+          </p:spPr>
+        </p:pic>
+      </p:grpSp>
+      <p:sp>
+        <p:nvSpPr>
+          <p:cNvPr id="58" name="TextBox 57"/>
           <p:cNvSpPr txBox="1"/>
           <p:nvPr/>
         </p:nvSpPr>
         <p:spPr>
           <a:xfrm>
-            <a:off x="10927080" y="6327648"/>
+            <a:off x="10927080" y="6336792"/>
             <a:ext cx="1188720" cy="320040"/>
           </a:xfrm>
           <a:prstGeom prst="rect">

</xml_diff>